<commit_message>
Add full-data figure slides to presentation (slides 8 and 9)
- Slide 8: before/after bar chart for full-data pipeline
- Slide 9: adaptation curve for full-data pipeline
- Deck is now 13 slides (was 11)
</commit_message>
<xml_diff>
--- a/presentation.pptx
+++ b/presentation.pptx
@@ -16,6 +16,8 @@
     <p:sldId id="264" r:id="rId15"/>
     <p:sldId id="265" r:id="rId16"/>
     <p:sldId id="266" r:id="rId17"/>
+    <p:sldId id="267" r:id="rId18"/>
+    <p:sldId id="268" r:id="rId19"/>
   </p:sldIdLst>
   <p:sldSz cx="12188952" cy="6858000" type="screen4x3"/>
   <p:notesSz cx="6858000" cy="9144000"/>
@@ -3451,7 +3453,7 @@
                 </a:solidFill>
                 <a:latin typeface="Calibri"/>
               </a:rPr>
-              <a:t>Conclusion</a:t>
+              <a:t>Key Finding: The Natural Experiment</a:t>
             </a:r>
           </a:p>
         </p:txBody>
@@ -3464,129 +3466,812 @@
         </p:nvSpPr>
         <p:spPr>
           <a:xfrm>
-            <a:off x="457200" y="1143000"/>
-            <a:ext cx="11247120" cy="4754880"/>
-          </a:xfrm>
-          <a:prstGeom prst="rect">
-            <a:avLst/>
-          </a:prstGeom>
-          <a:noFill/>
-        </p:spPr>
-        <p:txBody>
-          <a:bodyPr wrap="square">
-            <a:spAutoFit/>
-          </a:bodyPr>
-          <a:lstStyle/>
-          <a:p>
-            <a:pPr algn="l">
-              <a:spcAft>
-                <a:spcPts val="600"/>
-              </a:spcAft>
-            </a:pPr>
-            <a:r>
-              <a:rPr sz="1600">
+            <a:off x="320040" y="658368"/>
+            <a:ext cx="11430000" cy="347472"/>
+          </a:xfrm>
+          <a:prstGeom prst="rect">
+            <a:avLst/>
+          </a:prstGeom>
+          <a:noFill/>
+        </p:spPr>
+        <p:txBody>
+          <a:bodyPr wrap="square">
+            <a:spAutoFit/>
+          </a:bodyPr>
+          <a:lstStyle/>
+          <a:p>
+            <a:pPr algn="l"/>
+            <a:r>
+              <a:rPr sz="1400" b="0" i="0">
+                <a:solidFill>
+                  <a:srgbClr val="4C9BE8"/>
+                </a:solidFill>
+                <a:latin typeface="Calibri"/>
+              </a:rPr>
+              <a:t>One variable changed — night flips</a:t>
+            </a:r>
+          </a:p>
+        </p:txBody>
+      </p:sp>
+      <p:sp>
+        <p:nvSpPr>
+          <p:cNvPr id="5" name="Rectangle 4"/>
+          <p:cNvSpPr/>
+          <p:nvPr/>
+        </p:nvSpPr>
+        <p:spPr>
+          <a:xfrm>
+            <a:off x="365760" y="1097280"/>
+            <a:ext cx="11430000" cy="914400"/>
+          </a:xfrm>
+          <a:prstGeom prst="rect">
+            <a:avLst/>
+          </a:prstGeom>
+          <a:solidFill>
+            <a:srgbClr val="EEF4FB"/>
+          </a:solidFill>
+          <a:ln w="12700">
+            <a:solidFill>
+              <a:srgbClr val="4C9BE8"/>
+            </a:solidFill>
+          </a:ln>
+        </p:spPr>
+        <p:style>
+          <a:lnRef idx="1">
+            <a:schemeClr val="accent1"/>
+          </a:lnRef>
+          <a:fillRef idx="3">
+            <a:schemeClr val="accent1"/>
+          </a:fillRef>
+          <a:effectRef idx="2">
+            <a:schemeClr val="accent1"/>
+          </a:effectRef>
+          <a:fontRef idx="minor">
+            <a:schemeClr val="lt1"/>
+          </a:fontRef>
+        </p:style>
+        <p:txBody>
+          <a:bodyPr rtlCol="0" anchor="ctr"/>
+          <a:lstStyle/>
+          <a:p>
+            <a:pPr algn="ctr"/>
+          </a:p>
+        </p:txBody>
+      </p:sp>
+      <p:sp>
+        <p:nvSpPr>
+          <p:cNvPr id="6" name="TextBox 5"/>
+          <p:cNvSpPr txBox="1"/>
+          <p:nvPr/>
+        </p:nvSpPr>
+        <p:spPr>
+          <a:xfrm>
+            <a:off x="548640" y="1170432"/>
+            <a:ext cx="11064240" cy="777240"/>
+          </a:xfrm>
+          <a:prstGeom prst="rect">
+            <a:avLst/>
+          </a:prstGeom>
+          <a:noFill/>
+        </p:spPr>
+        <p:txBody>
+          <a:bodyPr wrap="square">
+            <a:spAutoFit/>
+          </a:bodyPr>
+          <a:lstStyle/>
+          <a:p>
+            <a:pPr algn="ctr"/>
+            <a:r>
+              <a:rPr sz="1500" b="0" i="1">
+                <a:solidFill>
+                  <a:srgbClr val="1A4F8A"/>
+                </a:solidFill>
+                <a:latin typeface="Calibri"/>
+              </a:rPr>
+              <a:t>The two runs are identical except for Step 1 dataset size. Everything else — backbone, training procedure, Step 2 config — is the same.</a:t>
+            </a:r>
+          </a:p>
+        </p:txBody>
+      </p:sp>
+      <p:sp>
+        <p:nvSpPr>
+          <p:cNvPr id="7" name="Rectangle 6"/>
+          <p:cNvSpPr/>
+          <p:nvPr/>
+        </p:nvSpPr>
+        <p:spPr>
+          <a:xfrm>
+            <a:off x="365760" y="2194560"/>
+            <a:ext cx="5486400" cy="4297680"/>
+          </a:xfrm>
+          <a:prstGeom prst="rect">
+            <a:avLst/>
+          </a:prstGeom>
+          <a:solidFill>
+            <a:srgbClr val="EEF4FB"/>
+          </a:solidFill>
+          <a:ln w="12700">
+            <a:solidFill>
+              <a:srgbClr val="4C9BE8"/>
+            </a:solidFill>
+          </a:ln>
+        </p:spPr>
+        <p:style>
+          <a:lnRef idx="1">
+            <a:schemeClr val="accent1"/>
+          </a:lnRef>
+          <a:fillRef idx="3">
+            <a:schemeClr val="accent1"/>
+          </a:fillRef>
+          <a:effectRef idx="2">
+            <a:schemeClr val="accent1"/>
+          </a:effectRef>
+          <a:fontRef idx="minor">
+            <a:schemeClr val="lt1"/>
+          </a:fontRef>
+        </p:style>
+        <p:txBody>
+          <a:bodyPr rtlCol="0" anchor="ctr"/>
+          <a:lstStyle/>
+          <a:p>
+            <a:pPr algn="ctr"/>
+          </a:p>
+        </p:txBody>
+      </p:sp>
+      <p:sp>
+        <p:nvSpPr>
+          <p:cNvPr id="8" name="TextBox 7"/>
+          <p:cNvSpPr txBox="1"/>
+          <p:nvPr/>
+        </p:nvSpPr>
+        <p:spPr>
+          <a:xfrm>
+            <a:off x="502920" y="2286000"/>
+            <a:ext cx="5212080" cy="365760"/>
+          </a:xfrm>
+          <a:prstGeom prst="rect">
+            <a:avLst/>
+          </a:prstGeom>
+          <a:noFill/>
+        </p:spPr>
+        <p:txBody>
+          <a:bodyPr wrap="square">
+            <a:spAutoFit/>
+          </a:bodyPr>
+          <a:lstStyle/>
+          <a:p>
+            <a:pPr algn="l"/>
+            <a:r>
+              <a:rPr sz="1600" b="1" i="0">
+                <a:solidFill>
+                  <a:srgbClr val="1A4F8A"/>
+                </a:solidFill>
+                <a:latin typeface="Calibri"/>
+              </a:rPr>
+              <a:t>Partial-data</a:t>
+            </a:r>
+          </a:p>
+        </p:txBody>
+      </p:sp>
+      <p:sp>
+        <p:nvSpPr>
+          <p:cNvPr id="9" name="TextBox 8"/>
+          <p:cNvSpPr txBox="1"/>
+          <p:nvPr/>
+        </p:nvSpPr>
+        <p:spPr>
+          <a:xfrm>
+            <a:off x="502920" y="2697480"/>
+            <a:ext cx="5212080" cy="457200"/>
+          </a:xfrm>
+          <a:prstGeom prst="rect">
+            <a:avLst/>
+          </a:prstGeom>
+          <a:noFill/>
+        </p:spPr>
+        <p:txBody>
+          <a:bodyPr wrap="square">
+            <a:spAutoFit/>
+          </a:bodyPr>
+          <a:lstStyle/>
+          <a:p>
+            <a:pPr algn="l"/>
+            <a:r>
+              <a:rPr sz="1300" b="0" i="0">
+                <a:solidFill>
+                  <a:srgbClr val="555555"/>
+                </a:solidFill>
+                <a:latin typeface="Calibri"/>
+              </a:rPr>
+              <a:t>Step 1: 30.30% CS val
+(~10K GTA5 pairs)</a:t>
+            </a:r>
+          </a:p>
+        </p:txBody>
+      </p:sp>
+      <p:sp>
+        <p:nvSpPr>
+          <p:cNvPr id="10" name="TextBox 9"/>
+          <p:cNvSpPr txBox="1"/>
+          <p:nvPr/>
+        </p:nvSpPr>
+        <p:spPr>
+          <a:xfrm>
+            <a:off x="502920" y="3200400"/>
+            <a:ext cx="2286000" cy="320040"/>
+          </a:xfrm>
+          <a:prstGeom prst="rect">
+            <a:avLst/>
+          </a:prstGeom>
+          <a:noFill/>
+        </p:spPr>
+        <p:txBody>
+          <a:bodyPr wrap="square">
+            <a:spAutoFit/>
+          </a:bodyPr>
+          <a:lstStyle/>
+          <a:p>
+            <a:pPr algn="l"/>
+            <a:r>
+              <a:rPr sz="1200" b="1" i="0">
                 <a:solidFill>
                   <a:srgbClr val="1A1A1A"/>
                 </a:solidFill>
                 <a:latin typeface="Calibri"/>
               </a:rPr>
-              <a:t>• Step 2 consistently improves ACDC segmentation — +5.52 pp (partial) and +6.11 pp (full-data)</a:t>
-            </a:r>
-          </a:p>
-          <a:p>
-            <a:pPr algn="l">
-              <a:spcAft>
-                <a:spcPts val="600"/>
-              </a:spcAft>
-            </a:pPr>
-            <a:r>
-              <a:rPr sz="1600">
+              <a:t>Night Before:</a:t>
+            </a:r>
+          </a:p>
+        </p:txBody>
+      </p:sp>
+      <p:sp>
+        <p:nvSpPr>
+          <p:cNvPr id="11" name="TextBox 10"/>
+          <p:cNvSpPr txBox="1"/>
+          <p:nvPr/>
+        </p:nvSpPr>
+        <p:spPr>
+          <a:xfrm>
+            <a:off x="2834640" y="3200400"/>
+            <a:ext cx="2743200" cy="320040"/>
+          </a:xfrm>
+          <a:prstGeom prst="rect">
+            <a:avLst/>
+          </a:prstGeom>
+          <a:noFill/>
+        </p:spPr>
+        <p:txBody>
+          <a:bodyPr wrap="square">
+            <a:spAutoFit/>
+          </a:bodyPr>
+          <a:lstStyle/>
+          <a:p>
+            <a:pPr algn="l"/>
+            <a:r>
+              <a:rPr sz="1400" b="1" i="0">
+                <a:solidFill>
+                  <a:srgbClr val="E8A23C"/>
+                </a:solidFill>
+                <a:latin typeface="Calibri"/>
+              </a:rPr>
+              <a:t>11.5%</a:t>
+            </a:r>
+          </a:p>
+        </p:txBody>
+      </p:sp>
+      <p:sp>
+        <p:nvSpPr>
+          <p:cNvPr id="12" name="TextBox 11"/>
+          <p:cNvSpPr txBox="1"/>
+          <p:nvPr/>
+        </p:nvSpPr>
+        <p:spPr>
+          <a:xfrm>
+            <a:off x="502920" y="3566160"/>
+            <a:ext cx="2286000" cy="320040"/>
+          </a:xfrm>
+          <a:prstGeom prst="rect">
+            <a:avLst/>
+          </a:prstGeom>
+          <a:noFill/>
+        </p:spPr>
+        <p:txBody>
+          <a:bodyPr wrap="square">
+            <a:spAutoFit/>
+          </a:bodyPr>
+          <a:lstStyle/>
+          <a:p>
+            <a:pPr algn="l"/>
+            <a:r>
+              <a:rPr sz="1200" b="1" i="0">
                 <a:solidFill>
                   <a:srgbClr val="1A1A1A"/>
                 </a:solidFill>
                 <a:latin typeface="Calibri"/>
               </a:rPr>
-              <a:t>• Fog benefits most; rain and snow improve substantially; night is the hardest condition</a:t>
-            </a:r>
-          </a:p>
-          <a:p>
-            <a:pPr algn="l">
-              <a:spcAft>
-                <a:spcPts val="600"/>
-              </a:spcAft>
-            </a:pPr>
-            <a:r>
-              <a:rPr sz="1600">
+              <a:t>Night After:</a:t>
+            </a:r>
+          </a:p>
+        </p:txBody>
+      </p:sp>
+      <p:sp>
+        <p:nvSpPr>
+          <p:cNvPr id="13" name="TextBox 12"/>
+          <p:cNvSpPr txBox="1"/>
+          <p:nvPr/>
+        </p:nvSpPr>
+        <p:spPr>
+          <a:xfrm>
+            <a:off x="2834640" y="3566160"/>
+            <a:ext cx="2743200" cy="320040"/>
+          </a:xfrm>
+          <a:prstGeom prst="rect">
+            <a:avLst/>
+          </a:prstGeom>
+          <a:noFill/>
+        </p:spPr>
+        <p:txBody>
+          <a:bodyPr wrap="square">
+            <a:spAutoFit/>
+          </a:bodyPr>
+          <a:lstStyle/>
+          <a:p>
+            <a:pPr algn="l"/>
+            <a:r>
+              <a:rPr sz="1400" b="1" i="0">
+                <a:solidFill>
+                  <a:srgbClr val="E8A23C"/>
+                </a:solidFill>
+                <a:latin typeface="Calibri"/>
+              </a:rPr>
+              <a:t>8.4%</a:t>
+            </a:r>
+          </a:p>
+        </p:txBody>
+      </p:sp>
+      <p:sp>
+        <p:nvSpPr>
+          <p:cNvPr id="14" name="Rectangle 13"/>
+          <p:cNvSpPr/>
+          <p:nvPr/>
+        </p:nvSpPr>
+        <p:spPr>
+          <a:xfrm>
+            <a:off x="502920" y="4023360"/>
+            <a:ext cx="5029200" cy="502920"/>
+          </a:xfrm>
+          <a:prstGeom prst="rect">
+            <a:avLst/>
+          </a:prstGeom>
+          <a:solidFill>
+            <a:srgbClr val="1A4F8A"/>
+          </a:solidFill>
+          <a:ln>
+            <a:noFill/>
+          </a:ln>
+        </p:spPr>
+        <p:style>
+          <a:lnRef idx="1">
+            <a:schemeClr val="accent1"/>
+          </a:lnRef>
+          <a:fillRef idx="3">
+            <a:schemeClr val="accent1"/>
+          </a:fillRef>
+          <a:effectRef idx="2">
+            <a:schemeClr val="accent1"/>
+          </a:effectRef>
+          <a:fontRef idx="minor">
+            <a:schemeClr val="lt1"/>
+          </a:fontRef>
+        </p:style>
+        <p:txBody>
+          <a:bodyPr rtlCol="0" anchor="ctr"/>
+          <a:lstStyle/>
+          <a:p>
+            <a:pPr algn="ctr"/>
+          </a:p>
+        </p:txBody>
+      </p:sp>
+      <p:sp>
+        <p:nvSpPr>
+          <p:cNvPr id="15" name="TextBox 14"/>
+          <p:cNvSpPr txBox="1"/>
+          <p:nvPr/>
+        </p:nvSpPr>
+        <p:spPr>
+          <a:xfrm>
+            <a:off x="502920" y="4023360"/>
+            <a:ext cx="5029200" cy="502920"/>
+          </a:xfrm>
+          <a:prstGeom prst="rect">
+            <a:avLst/>
+          </a:prstGeom>
+          <a:noFill/>
+        </p:spPr>
+        <p:txBody>
+          <a:bodyPr wrap="square">
+            <a:spAutoFit/>
+          </a:bodyPr>
+          <a:lstStyle/>
+          <a:p>
+            <a:pPr algn="ctr"/>
+            <a:r>
+              <a:rPr sz="1600" b="1" i="0">
+                <a:solidFill>
+                  <a:srgbClr val="C0392B"/>
+                </a:solidFill>
+                <a:latin typeface="Calibri"/>
+              </a:rPr>
+              <a:t>−3.1 pp  REGRESSION</a:t>
+            </a:r>
+          </a:p>
+        </p:txBody>
+      </p:sp>
+      <p:sp>
+        <p:nvSpPr>
+          <p:cNvPr id="16" name="Rectangle 15"/>
+          <p:cNvSpPr/>
+          <p:nvPr/>
+        </p:nvSpPr>
+        <p:spPr>
+          <a:xfrm>
+            <a:off x="6217920" y="2194560"/>
+            <a:ext cx="5486400" cy="4297680"/>
+          </a:xfrm>
+          <a:prstGeom prst="rect">
+            <a:avLst/>
+          </a:prstGeom>
+          <a:solidFill>
+            <a:srgbClr val="EEF4FB"/>
+          </a:solidFill>
+          <a:ln w="12700">
+            <a:solidFill>
+              <a:srgbClr val="4C9BE8"/>
+            </a:solidFill>
+          </a:ln>
+        </p:spPr>
+        <p:style>
+          <a:lnRef idx="1">
+            <a:schemeClr val="accent1"/>
+          </a:lnRef>
+          <a:fillRef idx="3">
+            <a:schemeClr val="accent1"/>
+          </a:fillRef>
+          <a:effectRef idx="2">
+            <a:schemeClr val="accent1"/>
+          </a:effectRef>
+          <a:fontRef idx="minor">
+            <a:schemeClr val="lt1"/>
+          </a:fontRef>
+        </p:style>
+        <p:txBody>
+          <a:bodyPr rtlCol="0" anchor="ctr"/>
+          <a:lstStyle/>
+          <a:p>
+            <a:pPr algn="ctr"/>
+          </a:p>
+        </p:txBody>
+      </p:sp>
+      <p:sp>
+        <p:nvSpPr>
+          <p:cNvPr id="17" name="TextBox 16"/>
+          <p:cNvSpPr txBox="1"/>
+          <p:nvPr/>
+        </p:nvSpPr>
+        <p:spPr>
+          <a:xfrm>
+            <a:off x="6355080" y="2286000"/>
+            <a:ext cx="5212080" cy="365760"/>
+          </a:xfrm>
+          <a:prstGeom prst="rect">
+            <a:avLst/>
+          </a:prstGeom>
+          <a:noFill/>
+        </p:spPr>
+        <p:txBody>
+          <a:bodyPr wrap="square">
+            <a:spAutoFit/>
+          </a:bodyPr>
+          <a:lstStyle/>
+          <a:p>
+            <a:pPr algn="l"/>
+            <a:r>
+              <a:rPr sz="1600" b="1" i="0">
+                <a:solidFill>
+                  <a:srgbClr val="1A4F8A"/>
+                </a:solidFill>
+                <a:latin typeface="Calibri"/>
+              </a:rPr>
+              <a:t>Full-data</a:t>
+            </a:r>
+          </a:p>
+        </p:txBody>
+      </p:sp>
+      <p:sp>
+        <p:nvSpPr>
+          <p:cNvPr id="18" name="TextBox 17"/>
+          <p:cNvSpPr txBox="1"/>
+          <p:nvPr/>
+        </p:nvSpPr>
+        <p:spPr>
+          <a:xfrm>
+            <a:off x="6355080" y="2697480"/>
+            <a:ext cx="5212080" cy="457200"/>
+          </a:xfrm>
+          <a:prstGeom prst="rect">
+            <a:avLst/>
+          </a:prstGeom>
+          <a:noFill/>
+        </p:spPr>
+        <p:txBody>
+          <a:bodyPr wrap="square">
+            <a:spAutoFit/>
+          </a:bodyPr>
+          <a:lstStyle/>
+          <a:p>
+            <a:pPr algn="l"/>
+            <a:r>
+              <a:rPr sz="1300" b="0" i="0">
+                <a:solidFill>
+                  <a:srgbClr val="555555"/>
+                </a:solidFill>
+                <a:latin typeface="Calibri"/>
+              </a:rPr>
+              <a:t>Step 1: 38.90% CS val
+(24,966 GTA5 pairs)</a:t>
+            </a:r>
+          </a:p>
+        </p:txBody>
+      </p:sp>
+      <p:sp>
+        <p:nvSpPr>
+          <p:cNvPr id="19" name="TextBox 18"/>
+          <p:cNvSpPr txBox="1"/>
+          <p:nvPr/>
+        </p:nvSpPr>
+        <p:spPr>
+          <a:xfrm>
+            <a:off x="6355080" y="3200400"/>
+            <a:ext cx="2286000" cy="320040"/>
+          </a:xfrm>
+          <a:prstGeom prst="rect">
+            <a:avLst/>
+          </a:prstGeom>
+          <a:noFill/>
+        </p:spPr>
+        <p:txBody>
+          <a:bodyPr wrap="square">
+            <a:spAutoFit/>
+          </a:bodyPr>
+          <a:lstStyle/>
+          <a:p>
+            <a:pPr algn="l"/>
+            <a:r>
+              <a:rPr sz="1200" b="1" i="0">
                 <a:solidFill>
                   <a:srgbClr val="1A1A1A"/>
                 </a:solidFill>
                 <a:latin typeface="Calibri"/>
               </a:rPr>
-              <a:t>• Full-data run: every condition improves, including night (+1.74 pp)</a:t>
-            </a:r>
-          </a:p>
-          <a:p>
-            <a:pPr algn="l">
-              <a:spcAft>
-                <a:spcPts val="600"/>
-              </a:spcAft>
-            </a:pPr>
-            <a:r>
-              <a:rPr sz="1600">
+              <a:t>Night Before:</a:t>
+            </a:r>
+          </a:p>
+        </p:txBody>
+      </p:sp>
+      <p:sp>
+        <p:nvSpPr>
+          <p:cNvPr id="20" name="TextBox 19"/>
+          <p:cNvSpPr txBox="1"/>
+          <p:nvPr/>
+        </p:nvSpPr>
+        <p:spPr>
+          <a:xfrm>
+            <a:off x="8686800" y="3200400"/>
+            <a:ext cx="2743200" cy="320040"/>
+          </a:xfrm>
+          <a:prstGeom prst="rect">
+            <a:avLst/>
+          </a:prstGeom>
+          <a:noFill/>
+        </p:spPr>
+        <p:txBody>
+          <a:bodyPr wrap="square">
+            <a:spAutoFit/>
+          </a:bodyPr>
+          <a:lstStyle/>
+          <a:p>
+            <a:pPr algn="l"/>
+            <a:r>
+              <a:rPr sz="1400" b="1" i="0">
+                <a:solidFill>
+                  <a:srgbClr val="E8A23C"/>
+                </a:solidFill>
+                <a:latin typeface="Calibri"/>
+              </a:rPr>
+              <a:t>15.02%</a:t>
+            </a:r>
+          </a:p>
+        </p:txBody>
+      </p:sp>
+      <p:sp>
+        <p:nvSpPr>
+          <p:cNvPr id="21" name="TextBox 20"/>
+          <p:cNvSpPr txBox="1"/>
+          <p:nvPr/>
+        </p:nvSpPr>
+        <p:spPr>
+          <a:xfrm>
+            <a:off x="6355080" y="3566160"/>
+            <a:ext cx="2286000" cy="320040"/>
+          </a:xfrm>
+          <a:prstGeom prst="rect">
+            <a:avLst/>
+          </a:prstGeom>
+          <a:noFill/>
+        </p:spPr>
+        <p:txBody>
+          <a:bodyPr wrap="square">
+            <a:spAutoFit/>
+          </a:bodyPr>
+          <a:lstStyle/>
+          <a:p>
+            <a:pPr algn="l"/>
+            <a:r>
+              <a:rPr sz="1200" b="1" i="0">
                 <a:solidFill>
                   <a:srgbClr val="1A1A1A"/>
                 </a:solidFill>
                 <a:latin typeface="Calibri"/>
               </a:rPr>
-              <a:t>• Natural experiment: the two runs isolate Step 1 quality as the causal mechanism for night behavior</a:t>
-            </a:r>
-          </a:p>
-          <a:p>
-            <a:pPr algn="l">
-              <a:spcAft>
-                <a:spcPts val="600"/>
-              </a:spcAft>
-            </a:pPr>
-            <a:r>
-              <a:rPr sz="1600">
-                <a:solidFill>
-                  <a:srgbClr val="1A1A1A"/>
-                </a:solidFill>
-                <a:latin typeface="Calibri"/>
-              </a:rPr>
-              <a:t>• Night regression is NOT a fundamental limitation — it is a consequence of a weak Step 1 model</a:t>
-            </a:r>
-          </a:p>
-          <a:p>
-            <a:pPr algn="l">
-              <a:spcAft>
-                <a:spcPts val="600"/>
-              </a:spcAft>
-            </a:pPr>
-            <a:r>
-              <a:rPr sz="1600">
-                <a:solidFill>
-                  <a:srgbClr val="1A1A1A"/>
-                </a:solidFill>
-                <a:latin typeface="Calibri"/>
-              </a:rPr>
-              <a:t>• Sequential UDA factorizes hard domain gaps; Step 1 quality is the primary design lever</a:t>
-            </a:r>
-          </a:p>
-          <a:p>
-            <a:pPr algn="l">
-              <a:spcAft>
-                <a:spcPts val="600"/>
-              </a:spcAft>
-            </a:pPr>
-            <a:r>
-              <a:rPr sz="1600">
-                <a:solidFill>
-                  <a:srgbClr val="1A1A1A"/>
-                </a:solidFill>
-                <a:latin typeface="Calibri"/>
-              </a:rPr>
-              <a:t>• Principle generalises beyond autonomous driving to any multi-hop domain adaptation setting</a:t>
+              <a:t>Night After:</a:t>
+            </a:r>
+          </a:p>
+        </p:txBody>
+      </p:sp>
+      <p:sp>
+        <p:nvSpPr>
+          <p:cNvPr id="22" name="TextBox 21"/>
+          <p:cNvSpPr txBox="1"/>
+          <p:nvPr/>
+        </p:nvSpPr>
+        <p:spPr>
+          <a:xfrm>
+            <a:off x="8686800" y="3566160"/>
+            <a:ext cx="2743200" cy="320040"/>
+          </a:xfrm>
+          <a:prstGeom prst="rect">
+            <a:avLst/>
+          </a:prstGeom>
+          <a:noFill/>
+        </p:spPr>
+        <p:txBody>
+          <a:bodyPr wrap="square">
+            <a:spAutoFit/>
+          </a:bodyPr>
+          <a:lstStyle/>
+          <a:p>
+            <a:pPr algn="l"/>
+            <a:r>
+              <a:rPr sz="1400" b="1" i="0">
+                <a:solidFill>
+                  <a:srgbClr val="E8A23C"/>
+                </a:solidFill>
+                <a:latin typeface="Calibri"/>
+              </a:rPr>
+              <a:t>16.77%</a:t>
+            </a:r>
+          </a:p>
+        </p:txBody>
+      </p:sp>
+      <p:sp>
+        <p:nvSpPr>
+          <p:cNvPr id="23" name="Rectangle 22"/>
+          <p:cNvSpPr/>
+          <p:nvPr/>
+        </p:nvSpPr>
+        <p:spPr>
+          <a:xfrm>
+            <a:off x="6355080" y="4023360"/>
+            <a:ext cx="5029200" cy="502920"/>
+          </a:xfrm>
+          <a:prstGeom prst="rect">
+            <a:avLst/>
+          </a:prstGeom>
+          <a:solidFill>
+            <a:srgbClr val="1A4F8A"/>
+          </a:solidFill>
+          <a:ln>
+            <a:noFill/>
+          </a:ln>
+        </p:spPr>
+        <p:style>
+          <a:lnRef idx="1">
+            <a:schemeClr val="accent1"/>
+          </a:lnRef>
+          <a:fillRef idx="3">
+            <a:schemeClr val="accent1"/>
+          </a:fillRef>
+          <a:effectRef idx="2">
+            <a:schemeClr val="accent1"/>
+          </a:effectRef>
+          <a:fontRef idx="minor">
+            <a:schemeClr val="lt1"/>
+          </a:fontRef>
+        </p:style>
+        <p:txBody>
+          <a:bodyPr rtlCol="0" anchor="ctr"/>
+          <a:lstStyle/>
+          <a:p>
+            <a:pPr algn="ctr"/>
+          </a:p>
+        </p:txBody>
+      </p:sp>
+      <p:sp>
+        <p:nvSpPr>
+          <p:cNvPr id="24" name="TextBox 23"/>
+          <p:cNvSpPr txBox="1"/>
+          <p:nvPr/>
+        </p:nvSpPr>
+        <p:spPr>
+          <a:xfrm>
+            <a:off x="6355080" y="4023360"/>
+            <a:ext cx="5029200" cy="502920"/>
+          </a:xfrm>
+          <a:prstGeom prst="rect">
+            <a:avLst/>
+          </a:prstGeom>
+          <a:noFill/>
+        </p:spPr>
+        <p:txBody>
+          <a:bodyPr wrap="square">
+            <a:spAutoFit/>
+          </a:bodyPr>
+          <a:lstStyle/>
+          <a:p>
+            <a:pPr algn="ctr"/>
+            <a:r>
+              <a:rPr sz="1600" b="1" i="0">
+                <a:solidFill>
+                  <a:srgbClr val="27AE60"/>
+                </a:solidFill>
+                <a:latin typeface="Calibri"/>
+              </a:rPr>
+              <a:t>+1.74 pp  IMPROVEMENT</a:t>
+            </a:r>
+          </a:p>
+        </p:txBody>
+      </p:sp>
+      <p:sp>
+        <p:nvSpPr>
+          <p:cNvPr id="25" name="TextBox 24"/>
+          <p:cNvSpPr txBox="1"/>
+          <p:nvPr/>
+        </p:nvSpPr>
+        <p:spPr>
+          <a:xfrm>
+            <a:off x="365760" y="6400800"/>
+            <a:ext cx="11430000" cy="365760"/>
+          </a:xfrm>
+          <a:prstGeom prst="rect">
+            <a:avLst/>
+          </a:prstGeom>
+          <a:noFill/>
+        </p:spPr>
+        <p:txBody>
+          <a:bodyPr wrap="square">
+            <a:spAutoFit/>
+          </a:bodyPr>
+          <a:lstStyle/>
+          <a:p>
+            <a:pPr algn="ctr"/>
+            <a:r>
+              <a:rPr sz="1400" b="1" i="0">
+                <a:solidFill>
+                  <a:srgbClr val="1A4F8A"/>
+                </a:solidFill>
+                <a:latin typeface="Calibri"/>
+              </a:rPr>
+              <a:t>→  Step 1 quality is the causal mechanism for night adaptation, not the method itself.</a:t>
             </a:r>
           </a:p>
         </p:txBody>
@@ -3600,6 +4285,983 @@
 </file>
 
 <file path=ppt/slides/slide11.xml><?xml version="1.0" encoding="utf-8"?>
+<p:sld xmlns:a="http://schemas.openxmlformats.org/drawingml/2006/main" xmlns:p="http://schemas.openxmlformats.org/presentationml/2006/main" xmlns:r="http://schemas.openxmlformats.org/officeDocument/2006/relationships">
+  <p:cSld>
+    <p:spTree>
+      <p:nvGrpSpPr>
+        <p:cNvPr id="1" name=""/>
+        <p:cNvGrpSpPr/>
+        <p:nvPr/>
+      </p:nvGrpSpPr>
+      <p:grpSpPr/>
+      <p:sp>
+        <p:nvSpPr>
+          <p:cNvPr id="2" name="Rectangle 1"/>
+          <p:cNvSpPr/>
+          <p:nvPr/>
+        </p:nvSpPr>
+        <p:spPr>
+          <a:xfrm>
+            <a:off x="0" y="0"/>
+            <a:ext cx="12188952" cy="1051560"/>
+          </a:xfrm>
+          <a:prstGeom prst="rect">
+            <a:avLst/>
+          </a:prstGeom>
+          <a:solidFill>
+            <a:srgbClr val="1A4F8A"/>
+          </a:solidFill>
+          <a:ln>
+            <a:noFill/>
+          </a:ln>
+        </p:spPr>
+        <p:style>
+          <a:lnRef idx="1">
+            <a:schemeClr val="accent1"/>
+          </a:lnRef>
+          <a:fillRef idx="3">
+            <a:schemeClr val="accent1"/>
+          </a:fillRef>
+          <a:effectRef idx="2">
+            <a:schemeClr val="accent1"/>
+          </a:effectRef>
+          <a:fontRef idx="minor">
+            <a:schemeClr val="lt1"/>
+          </a:fontRef>
+        </p:style>
+        <p:txBody>
+          <a:bodyPr rtlCol="0" anchor="ctr"/>
+          <a:lstStyle/>
+          <a:p>
+            <a:pPr algn="ctr"/>
+          </a:p>
+        </p:txBody>
+      </p:sp>
+      <p:sp>
+        <p:nvSpPr>
+          <p:cNvPr id="3" name="TextBox 2"/>
+          <p:cNvSpPr txBox="1"/>
+          <p:nvPr/>
+        </p:nvSpPr>
+        <p:spPr>
+          <a:xfrm>
+            <a:off x="320040" y="73152"/>
+            <a:ext cx="11430000" cy="594360"/>
+          </a:xfrm>
+          <a:prstGeom prst="rect">
+            <a:avLst/>
+          </a:prstGeom>
+          <a:noFill/>
+        </p:spPr>
+        <p:txBody>
+          <a:bodyPr wrap="square">
+            <a:spAutoFit/>
+          </a:bodyPr>
+          <a:lstStyle/>
+          <a:p>
+            <a:pPr algn="l"/>
+            <a:r>
+              <a:rPr sz="2800" b="1" i="0">
+                <a:solidFill>
+                  <a:srgbClr val="FFFFFF"/>
+                </a:solidFill>
+                <a:latin typeface="Calibri"/>
+              </a:rPr>
+              <a:t>Broader Applicability</a:t>
+            </a:r>
+          </a:p>
+        </p:txBody>
+      </p:sp>
+      <p:sp>
+        <p:nvSpPr>
+          <p:cNvPr id="4" name="TextBox 3"/>
+          <p:cNvSpPr txBox="1"/>
+          <p:nvPr/>
+        </p:nvSpPr>
+        <p:spPr>
+          <a:xfrm>
+            <a:off x="320040" y="658368"/>
+            <a:ext cx="11430000" cy="347472"/>
+          </a:xfrm>
+          <a:prstGeom prst="rect">
+            <a:avLst/>
+          </a:prstGeom>
+          <a:noFill/>
+        </p:spPr>
+        <p:txBody>
+          <a:bodyPr wrap="square">
+            <a:spAutoFit/>
+          </a:bodyPr>
+          <a:lstStyle/>
+          <a:p>
+            <a:pPr algn="l"/>
+            <a:r>
+              <a:rPr sz="1400" b="0" i="0">
+                <a:solidFill>
+                  <a:srgbClr val="4C9BE8"/>
+                </a:solidFill>
+                <a:latin typeface="Calibri"/>
+              </a:rPr>
+              <a:t>The principle extends beyond autonomous driving</a:t>
+            </a:r>
+          </a:p>
+        </p:txBody>
+      </p:sp>
+      <p:sp>
+        <p:nvSpPr>
+          <p:cNvPr id="5" name="TextBox 4"/>
+          <p:cNvSpPr txBox="1"/>
+          <p:nvPr/>
+        </p:nvSpPr>
+        <p:spPr>
+          <a:xfrm>
+            <a:off x="365760" y="1097280"/>
+            <a:ext cx="11430000" cy="457200"/>
+          </a:xfrm>
+          <a:prstGeom prst="rect">
+            <a:avLst/>
+          </a:prstGeom>
+          <a:noFill/>
+        </p:spPr>
+        <p:txBody>
+          <a:bodyPr wrap="square">
+            <a:spAutoFit/>
+          </a:bodyPr>
+          <a:lstStyle/>
+          <a:p>
+            <a:pPr algn="l"/>
+            <a:r>
+              <a:rPr sz="1500" b="0" i="0">
+                <a:solidFill>
+                  <a:srgbClr val="1A1A1A"/>
+                </a:solidFill>
+                <a:latin typeface="Calibri"/>
+              </a:rPr>
+              <a:t>Two-step UDA applies whenever a large domain gap can be factored through a labeled intermediate domain:</a:t>
+            </a:r>
+          </a:p>
+        </p:txBody>
+      </p:sp>
+      <p:sp>
+        <p:nvSpPr>
+          <p:cNvPr id="6" name="Rectangle 5"/>
+          <p:cNvSpPr/>
+          <p:nvPr/>
+        </p:nvSpPr>
+        <p:spPr>
+          <a:xfrm>
+            <a:off x="457200" y="1691640"/>
+            <a:ext cx="2468880" cy="2560320"/>
+          </a:xfrm>
+          <a:prstGeom prst="rect">
+            <a:avLst/>
+          </a:prstGeom>
+          <a:solidFill>
+            <a:srgbClr val="1A4F8A"/>
+          </a:solidFill>
+          <a:ln>
+            <a:noFill/>
+          </a:ln>
+        </p:spPr>
+        <p:style>
+          <a:lnRef idx="1">
+            <a:schemeClr val="accent1"/>
+          </a:lnRef>
+          <a:fillRef idx="3">
+            <a:schemeClr val="accent1"/>
+          </a:fillRef>
+          <a:effectRef idx="2">
+            <a:schemeClr val="accent1"/>
+          </a:effectRef>
+          <a:fontRef idx="minor">
+            <a:schemeClr val="lt1"/>
+          </a:fontRef>
+        </p:style>
+        <p:txBody>
+          <a:bodyPr rtlCol="0" anchor="ctr"/>
+          <a:lstStyle/>
+          <a:p>
+            <a:pPr algn="ctr"/>
+          </a:p>
+        </p:txBody>
+      </p:sp>
+      <p:sp>
+        <p:nvSpPr>
+          <p:cNvPr id="7" name="TextBox 6"/>
+          <p:cNvSpPr txBox="1"/>
+          <p:nvPr/>
+        </p:nvSpPr>
+        <p:spPr>
+          <a:xfrm>
+            <a:off x="457200" y="1691640"/>
+            <a:ext cx="2468880" cy="685800"/>
+          </a:xfrm>
+          <a:prstGeom prst="rect">
+            <a:avLst/>
+          </a:prstGeom>
+          <a:noFill/>
+        </p:spPr>
+        <p:txBody>
+          <a:bodyPr wrap="square">
+            <a:spAutoFit/>
+          </a:bodyPr>
+          <a:lstStyle/>
+          <a:p>
+            <a:pPr algn="ctr"/>
+            <a:r>
+              <a:rPr sz="1400" b="1" i="0">
+                <a:solidFill>
+                  <a:srgbClr val="FFFFFF"/>
+                </a:solidFill>
+                <a:latin typeface="Calibri"/>
+              </a:rPr>
+              <a:t>Autonomous
+Driving</a:t>
+            </a:r>
+          </a:p>
+        </p:txBody>
+      </p:sp>
+      <p:sp>
+        <p:nvSpPr>
+          <p:cNvPr id="8" name="TextBox 7"/>
+          <p:cNvSpPr txBox="1"/>
+          <p:nvPr/>
+        </p:nvSpPr>
+        <p:spPr>
+          <a:xfrm>
+            <a:off x="548640" y="2423160"/>
+            <a:ext cx="2286000" cy="1737360"/>
+          </a:xfrm>
+          <a:prstGeom prst="rect">
+            <a:avLst/>
+          </a:prstGeom>
+          <a:noFill/>
+        </p:spPr>
+        <p:txBody>
+          <a:bodyPr wrap="square">
+            <a:spAutoFit/>
+          </a:bodyPr>
+          <a:lstStyle/>
+          <a:p>
+            <a:pPr algn="ctr"/>
+            <a:r>
+              <a:rPr sz="1200" b="0" i="0">
+                <a:solidFill>
+                  <a:srgbClr val="4C9BE8"/>
+                </a:solidFill>
+                <a:latin typeface="Calibri"/>
+              </a:rPr>
+              <a:t>Synthetic game data
+→ Clean real scenes
+→ Adverse weather</a:t>
+            </a:r>
+          </a:p>
+        </p:txBody>
+      </p:sp>
+      <p:sp>
+        <p:nvSpPr>
+          <p:cNvPr id="9" name="Rectangle 8"/>
+          <p:cNvSpPr/>
+          <p:nvPr/>
+        </p:nvSpPr>
+        <p:spPr>
+          <a:xfrm>
+            <a:off x="3200400" y="1691640"/>
+            <a:ext cx="2468880" cy="2560320"/>
+          </a:xfrm>
+          <a:prstGeom prst="rect">
+            <a:avLst/>
+          </a:prstGeom>
+          <a:solidFill>
+            <a:srgbClr val="1A4F8A"/>
+          </a:solidFill>
+          <a:ln>
+            <a:noFill/>
+          </a:ln>
+        </p:spPr>
+        <p:style>
+          <a:lnRef idx="1">
+            <a:schemeClr val="accent1"/>
+          </a:lnRef>
+          <a:fillRef idx="3">
+            <a:schemeClr val="accent1"/>
+          </a:fillRef>
+          <a:effectRef idx="2">
+            <a:schemeClr val="accent1"/>
+          </a:effectRef>
+          <a:fontRef idx="minor">
+            <a:schemeClr val="lt1"/>
+          </a:fontRef>
+        </p:style>
+        <p:txBody>
+          <a:bodyPr rtlCol="0" anchor="ctr"/>
+          <a:lstStyle/>
+          <a:p>
+            <a:pPr algn="ctr"/>
+          </a:p>
+        </p:txBody>
+      </p:sp>
+      <p:sp>
+        <p:nvSpPr>
+          <p:cNvPr id="10" name="TextBox 9"/>
+          <p:cNvSpPr txBox="1"/>
+          <p:nvPr/>
+        </p:nvSpPr>
+        <p:spPr>
+          <a:xfrm>
+            <a:off x="3200400" y="1691640"/>
+            <a:ext cx="2468880" cy="685800"/>
+          </a:xfrm>
+          <a:prstGeom prst="rect">
+            <a:avLst/>
+          </a:prstGeom>
+          <a:noFill/>
+        </p:spPr>
+        <p:txBody>
+          <a:bodyPr wrap="square">
+            <a:spAutoFit/>
+          </a:bodyPr>
+          <a:lstStyle/>
+          <a:p>
+            <a:pPr algn="ctr"/>
+            <a:r>
+              <a:rPr sz="1400" b="1" i="0">
+                <a:solidFill>
+                  <a:srgbClr val="FFFFFF"/>
+                </a:solidFill>
+                <a:latin typeface="Calibri"/>
+              </a:rPr>
+              <a:t>Medical
+Imaging</a:t>
+            </a:r>
+          </a:p>
+        </p:txBody>
+      </p:sp>
+      <p:sp>
+        <p:nvSpPr>
+          <p:cNvPr id="11" name="TextBox 10"/>
+          <p:cNvSpPr txBox="1"/>
+          <p:nvPr/>
+        </p:nvSpPr>
+        <p:spPr>
+          <a:xfrm>
+            <a:off x="3291840" y="2423160"/>
+            <a:ext cx="2286000" cy="1737360"/>
+          </a:xfrm>
+          <a:prstGeom prst="rect">
+            <a:avLst/>
+          </a:prstGeom>
+          <a:noFill/>
+        </p:spPr>
+        <p:txBody>
+          <a:bodyPr wrap="square">
+            <a:spAutoFit/>
+          </a:bodyPr>
+          <a:lstStyle/>
+          <a:p>
+            <a:pPr algn="ctr"/>
+            <a:r>
+              <a:rPr sz="1200" b="0" i="0">
+                <a:solidFill>
+                  <a:srgbClr val="4C9BE8"/>
+                </a:solidFill>
+                <a:latin typeface="Calibri"/>
+              </a:rPr>
+              <a:t>Synthetic scans
+→ One scanner type
+→ Noisier scanner</a:t>
+            </a:r>
+          </a:p>
+        </p:txBody>
+      </p:sp>
+      <p:sp>
+        <p:nvSpPr>
+          <p:cNvPr id="12" name="Rectangle 11"/>
+          <p:cNvSpPr/>
+          <p:nvPr/>
+        </p:nvSpPr>
+        <p:spPr>
+          <a:xfrm>
+            <a:off x="5943600" y="1691640"/>
+            <a:ext cx="2468880" cy="2560320"/>
+          </a:xfrm>
+          <a:prstGeom prst="rect">
+            <a:avLst/>
+          </a:prstGeom>
+          <a:solidFill>
+            <a:srgbClr val="1A4F8A"/>
+          </a:solidFill>
+          <a:ln>
+            <a:noFill/>
+          </a:ln>
+        </p:spPr>
+        <p:style>
+          <a:lnRef idx="1">
+            <a:schemeClr val="accent1"/>
+          </a:lnRef>
+          <a:fillRef idx="3">
+            <a:schemeClr val="accent1"/>
+          </a:fillRef>
+          <a:effectRef idx="2">
+            <a:schemeClr val="accent1"/>
+          </a:effectRef>
+          <a:fontRef idx="minor">
+            <a:schemeClr val="lt1"/>
+          </a:fontRef>
+        </p:style>
+        <p:txBody>
+          <a:bodyPr rtlCol="0" anchor="ctr"/>
+          <a:lstStyle/>
+          <a:p>
+            <a:pPr algn="ctr"/>
+          </a:p>
+        </p:txBody>
+      </p:sp>
+      <p:sp>
+        <p:nvSpPr>
+          <p:cNvPr id="13" name="TextBox 12"/>
+          <p:cNvSpPr txBox="1"/>
+          <p:nvPr/>
+        </p:nvSpPr>
+        <p:spPr>
+          <a:xfrm>
+            <a:off x="5943600" y="1691640"/>
+            <a:ext cx="2468880" cy="685800"/>
+          </a:xfrm>
+          <a:prstGeom prst="rect">
+            <a:avLst/>
+          </a:prstGeom>
+          <a:noFill/>
+        </p:spPr>
+        <p:txBody>
+          <a:bodyPr wrap="square">
+            <a:spAutoFit/>
+          </a:bodyPr>
+          <a:lstStyle/>
+          <a:p>
+            <a:pPr algn="ctr"/>
+            <a:r>
+              <a:rPr sz="1400" b="1" i="0">
+                <a:solidFill>
+                  <a:srgbClr val="FFFFFF"/>
+                </a:solidFill>
+                <a:latin typeface="Calibri"/>
+              </a:rPr>
+              <a:t>Satellite
+Imagery</a:t>
+            </a:r>
+          </a:p>
+        </p:txBody>
+      </p:sp>
+      <p:sp>
+        <p:nvSpPr>
+          <p:cNvPr id="14" name="TextBox 13"/>
+          <p:cNvSpPr txBox="1"/>
+          <p:nvPr/>
+        </p:nvSpPr>
+        <p:spPr>
+          <a:xfrm>
+            <a:off x="6035040" y="2423160"/>
+            <a:ext cx="2286000" cy="1737360"/>
+          </a:xfrm>
+          <a:prstGeom prst="rect">
+            <a:avLst/>
+          </a:prstGeom>
+          <a:noFill/>
+        </p:spPr>
+        <p:txBody>
+          <a:bodyPr wrap="square">
+            <a:spAutoFit/>
+          </a:bodyPr>
+          <a:lstStyle/>
+          <a:p>
+            <a:pPr algn="ctr"/>
+            <a:r>
+              <a:rPr sz="1200" b="0" i="0">
+                <a:solidFill>
+                  <a:srgbClr val="4C9BE8"/>
+                </a:solidFill>
+                <a:latin typeface="Calibri"/>
+              </a:rPr>
+              <a:t>One season/region
+→ Intermediate domain
+→ Target region</a:t>
+            </a:r>
+          </a:p>
+        </p:txBody>
+      </p:sp>
+      <p:sp>
+        <p:nvSpPr>
+          <p:cNvPr id="15" name="Rectangle 14"/>
+          <p:cNvSpPr/>
+          <p:nvPr/>
+        </p:nvSpPr>
+        <p:spPr>
+          <a:xfrm>
+            <a:off x="8686800" y="1691640"/>
+            <a:ext cx="2468880" cy="2560320"/>
+          </a:xfrm>
+          <a:prstGeom prst="rect">
+            <a:avLst/>
+          </a:prstGeom>
+          <a:solidFill>
+            <a:srgbClr val="1A4F8A"/>
+          </a:solidFill>
+          <a:ln>
+            <a:noFill/>
+          </a:ln>
+        </p:spPr>
+        <p:style>
+          <a:lnRef idx="1">
+            <a:schemeClr val="accent1"/>
+          </a:lnRef>
+          <a:fillRef idx="3">
+            <a:schemeClr val="accent1"/>
+          </a:fillRef>
+          <a:effectRef idx="2">
+            <a:schemeClr val="accent1"/>
+          </a:effectRef>
+          <a:fontRef idx="minor">
+            <a:schemeClr val="lt1"/>
+          </a:fontRef>
+        </p:style>
+        <p:txBody>
+          <a:bodyPr rtlCol="0" anchor="ctr"/>
+          <a:lstStyle/>
+          <a:p>
+            <a:pPr algn="ctr"/>
+          </a:p>
+        </p:txBody>
+      </p:sp>
+      <p:sp>
+        <p:nvSpPr>
+          <p:cNvPr id="16" name="TextBox 15"/>
+          <p:cNvSpPr txBox="1"/>
+          <p:nvPr/>
+        </p:nvSpPr>
+        <p:spPr>
+          <a:xfrm>
+            <a:off x="8686800" y="1691640"/>
+            <a:ext cx="2468880" cy="685800"/>
+          </a:xfrm>
+          <a:prstGeom prst="rect">
+            <a:avLst/>
+          </a:prstGeom>
+          <a:noFill/>
+        </p:spPr>
+        <p:txBody>
+          <a:bodyPr wrap="square">
+            <a:spAutoFit/>
+          </a:bodyPr>
+          <a:lstStyle/>
+          <a:p>
+            <a:pPr algn="ctr"/>
+            <a:r>
+              <a:rPr sz="1400" b="1" i="0">
+                <a:solidFill>
+                  <a:srgbClr val="FFFFFF"/>
+                </a:solidFill>
+                <a:latin typeface="Calibri"/>
+              </a:rPr>
+              <a:t>Outdoor
+Robotics</a:t>
+            </a:r>
+          </a:p>
+        </p:txBody>
+      </p:sp>
+      <p:sp>
+        <p:nvSpPr>
+          <p:cNvPr id="17" name="TextBox 16"/>
+          <p:cNvSpPr txBox="1"/>
+          <p:nvPr/>
+        </p:nvSpPr>
+        <p:spPr>
+          <a:xfrm>
+            <a:off x="8778240" y="2423160"/>
+            <a:ext cx="2286000" cy="1737360"/>
+          </a:xfrm>
+          <a:prstGeom prst="rect">
+            <a:avLst/>
+          </a:prstGeom>
+          <a:noFill/>
+        </p:spPr>
+        <p:txBody>
+          <a:bodyPr wrap="square">
+            <a:spAutoFit/>
+          </a:bodyPr>
+          <a:lstStyle/>
+          <a:p>
+            <a:pPr algn="ctr"/>
+            <a:r>
+              <a:rPr sz="1200" b="0" i="0">
+                <a:solidFill>
+                  <a:srgbClr val="4C9BE8"/>
+                </a:solidFill>
+                <a:latin typeface="Calibri"/>
+              </a:rPr>
+              <a:t>Simulation
+→ Controlled env
+→ Unstructured env</a:t>
+            </a:r>
+          </a:p>
+        </p:txBody>
+      </p:sp>
+      <p:sp>
+        <p:nvSpPr>
+          <p:cNvPr id="18" name="Rectangle 17"/>
+          <p:cNvSpPr/>
+          <p:nvPr/>
+        </p:nvSpPr>
+        <p:spPr>
+          <a:xfrm>
+            <a:off x="365760" y="4434840"/>
+            <a:ext cx="11430000" cy="1371600"/>
+          </a:xfrm>
+          <a:prstGeom prst="rect">
+            <a:avLst/>
+          </a:prstGeom>
+          <a:solidFill>
+            <a:srgbClr val="EEF4FB"/>
+          </a:solidFill>
+          <a:ln w="12700">
+            <a:solidFill>
+              <a:srgbClr val="4C9BE8"/>
+            </a:solidFill>
+          </a:ln>
+        </p:spPr>
+        <p:style>
+          <a:lnRef idx="1">
+            <a:schemeClr val="accent1"/>
+          </a:lnRef>
+          <a:fillRef idx="3">
+            <a:schemeClr val="accent1"/>
+          </a:fillRef>
+          <a:effectRef idx="2">
+            <a:schemeClr val="accent1"/>
+          </a:effectRef>
+          <a:fontRef idx="minor">
+            <a:schemeClr val="lt1"/>
+          </a:fontRef>
+        </p:style>
+        <p:txBody>
+          <a:bodyPr rtlCol="0" anchor="ctr"/>
+          <a:lstStyle/>
+          <a:p>
+            <a:pPr algn="ctr"/>
+          </a:p>
+        </p:txBody>
+      </p:sp>
+      <p:sp>
+        <p:nvSpPr>
+          <p:cNvPr id="19" name="TextBox 18"/>
+          <p:cNvSpPr txBox="1"/>
+          <p:nvPr/>
+        </p:nvSpPr>
+        <p:spPr>
+          <a:xfrm>
+            <a:off x="548640" y="4526280"/>
+            <a:ext cx="11064240" cy="320040"/>
+          </a:xfrm>
+          <a:prstGeom prst="rect">
+            <a:avLst/>
+          </a:prstGeom>
+          <a:noFill/>
+        </p:spPr>
+        <p:txBody>
+          <a:bodyPr wrap="square">
+            <a:spAutoFit/>
+          </a:bodyPr>
+          <a:lstStyle/>
+          <a:p>
+            <a:pPr algn="l"/>
+            <a:r>
+              <a:rPr sz="1400" b="1" i="0">
+                <a:solidFill>
+                  <a:srgbClr val="1A4F8A"/>
+                </a:solidFill>
+                <a:latin typeface="Calibri"/>
+              </a:rPr>
+              <a:t>Structural requirement for two-step UDA:</a:t>
+            </a:r>
+          </a:p>
+        </p:txBody>
+      </p:sp>
+      <p:sp>
+        <p:nvSpPr>
+          <p:cNvPr id="20" name="TextBox 19"/>
+          <p:cNvSpPr txBox="1"/>
+          <p:nvPr/>
+        </p:nvSpPr>
+        <p:spPr>
+          <a:xfrm>
+            <a:off x="548640" y="4892040"/>
+            <a:ext cx="11064240" cy="822960"/>
+          </a:xfrm>
+          <a:prstGeom prst="rect">
+            <a:avLst/>
+          </a:prstGeom>
+          <a:noFill/>
+        </p:spPr>
+        <p:txBody>
+          <a:bodyPr wrap="square">
+            <a:spAutoFit/>
+          </a:bodyPr>
+          <a:lstStyle/>
+          <a:p>
+            <a:pPr algn="l"/>
+            <a:r>
+              <a:rPr sz="1300" b="0" i="0">
+                <a:solidFill>
+                  <a:srgbClr val="1A1A1A"/>
+                </a:solidFill>
+                <a:latin typeface="Calibri"/>
+              </a:rPr>
+              <a:t>Labeled synthetic source  ·  Accessible labeled intermediate domain  ·  Hard unlabeled final target
+Where the direct source→target gap is too large to bridge in one step.</a:t>
+            </a:r>
+          </a:p>
+        </p:txBody>
+      </p:sp>
+    </p:spTree>
+  </p:cSld>
+  <p:clrMapOvr>
+    <a:masterClrMapping/>
+  </p:clrMapOvr>
+</p:sld>
+</file>
+
+<file path=ppt/slides/slide12.xml><?xml version="1.0" encoding="utf-8"?>
+<p:sld xmlns:a="http://schemas.openxmlformats.org/drawingml/2006/main" xmlns:p="http://schemas.openxmlformats.org/presentationml/2006/main" xmlns:r="http://schemas.openxmlformats.org/officeDocument/2006/relationships">
+  <p:cSld>
+    <p:spTree>
+      <p:nvGrpSpPr>
+        <p:cNvPr id="1" name=""/>
+        <p:cNvGrpSpPr/>
+        <p:nvPr/>
+      </p:nvGrpSpPr>
+      <p:grpSpPr/>
+      <p:sp>
+        <p:nvSpPr>
+          <p:cNvPr id="2" name="Rectangle 1"/>
+          <p:cNvSpPr/>
+          <p:nvPr/>
+        </p:nvSpPr>
+        <p:spPr>
+          <a:xfrm>
+            <a:off x="0" y="0"/>
+            <a:ext cx="12188952" cy="1051560"/>
+          </a:xfrm>
+          <a:prstGeom prst="rect">
+            <a:avLst/>
+          </a:prstGeom>
+          <a:solidFill>
+            <a:srgbClr val="1A4F8A"/>
+          </a:solidFill>
+          <a:ln>
+            <a:noFill/>
+          </a:ln>
+        </p:spPr>
+        <p:style>
+          <a:lnRef idx="1">
+            <a:schemeClr val="accent1"/>
+          </a:lnRef>
+          <a:fillRef idx="3">
+            <a:schemeClr val="accent1"/>
+          </a:fillRef>
+          <a:effectRef idx="2">
+            <a:schemeClr val="accent1"/>
+          </a:effectRef>
+          <a:fontRef idx="minor">
+            <a:schemeClr val="lt1"/>
+          </a:fontRef>
+        </p:style>
+        <p:txBody>
+          <a:bodyPr rtlCol="0" anchor="ctr"/>
+          <a:lstStyle/>
+          <a:p>
+            <a:pPr algn="ctr"/>
+          </a:p>
+        </p:txBody>
+      </p:sp>
+      <p:sp>
+        <p:nvSpPr>
+          <p:cNvPr id="3" name="TextBox 2"/>
+          <p:cNvSpPr txBox="1"/>
+          <p:nvPr/>
+        </p:nvSpPr>
+        <p:spPr>
+          <a:xfrm>
+            <a:off x="320040" y="73152"/>
+            <a:ext cx="11430000" cy="594360"/>
+          </a:xfrm>
+          <a:prstGeom prst="rect">
+            <a:avLst/>
+          </a:prstGeom>
+          <a:noFill/>
+        </p:spPr>
+        <p:txBody>
+          <a:bodyPr wrap="square">
+            <a:spAutoFit/>
+          </a:bodyPr>
+          <a:lstStyle/>
+          <a:p>
+            <a:pPr algn="l"/>
+            <a:r>
+              <a:rPr sz="2800" b="1" i="0">
+                <a:solidFill>
+                  <a:srgbClr val="FFFFFF"/>
+                </a:solidFill>
+                <a:latin typeface="Calibri"/>
+              </a:rPr>
+              <a:t>Conclusion</a:t>
+            </a:r>
+          </a:p>
+        </p:txBody>
+      </p:sp>
+      <p:sp>
+        <p:nvSpPr>
+          <p:cNvPr id="4" name="TextBox 3"/>
+          <p:cNvSpPr txBox="1"/>
+          <p:nvPr/>
+        </p:nvSpPr>
+        <p:spPr>
+          <a:xfrm>
+            <a:off x="457200" y="1143000"/>
+            <a:ext cx="11247120" cy="4754880"/>
+          </a:xfrm>
+          <a:prstGeom prst="rect">
+            <a:avLst/>
+          </a:prstGeom>
+          <a:noFill/>
+        </p:spPr>
+        <p:txBody>
+          <a:bodyPr wrap="square">
+            <a:spAutoFit/>
+          </a:bodyPr>
+          <a:lstStyle/>
+          <a:p>
+            <a:pPr algn="l">
+              <a:spcAft>
+                <a:spcPts val="600"/>
+              </a:spcAft>
+            </a:pPr>
+            <a:r>
+              <a:rPr sz="1600">
+                <a:solidFill>
+                  <a:srgbClr val="1A1A1A"/>
+                </a:solidFill>
+                <a:latin typeface="Calibri"/>
+              </a:rPr>
+              <a:t>• Step 2 consistently improves ACDC segmentation — +5.52 pp (partial) and +6.11 pp (full-data)</a:t>
+            </a:r>
+          </a:p>
+          <a:p>
+            <a:pPr algn="l">
+              <a:spcAft>
+                <a:spcPts val="600"/>
+              </a:spcAft>
+            </a:pPr>
+            <a:r>
+              <a:rPr sz="1600">
+                <a:solidFill>
+                  <a:srgbClr val="1A1A1A"/>
+                </a:solidFill>
+                <a:latin typeface="Calibri"/>
+              </a:rPr>
+              <a:t>• Fog benefits most; rain and snow improve substantially; night is the hardest condition</a:t>
+            </a:r>
+          </a:p>
+          <a:p>
+            <a:pPr algn="l">
+              <a:spcAft>
+                <a:spcPts val="600"/>
+              </a:spcAft>
+            </a:pPr>
+            <a:r>
+              <a:rPr sz="1600">
+                <a:solidFill>
+                  <a:srgbClr val="1A1A1A"/>
+                </a:solidFill>
+                <a:latin typeface="Calibri"/>
+              </a:rPr>
+              <a:t>• Full-data run: every condition improves, including night (+1.74 pp)</a:t>
+            </a:r>
+          </a:p>
+          <a:p>
+            <a:pPr algn="l">
+              <a:spcAft>
+                <a:spcPts val="600"/>
+              </a:spcAft>
+            </a:pPr>
+            <a:r>
+              <a:rPr sz="1600">
+                <a:solidFill>
+                  <a:srgbClr val="1A1A1A"/>
+                </a:solidFill>
+                <a:latin typeface="Calibri"/>
+              </a:rPr>
+              <a:t>• Natural experiment: the two runs isolate Step 1 quality as the causal mechanism for night behavior</a:t>
+            </a:r>
+          </a:p>
+          <a:p>
+            <a:pPr algn="l">
+              <a:spcAft>
+                <a:spcPts val="600"/>
+              </a:spcAft>
+            </a:pPr>
+            <a:r>
+              <a:rPr sz="1600">
+                <a:solidFill>
+                  <a:srgbClr val="1A1A1A"/>
+                </a:solidFill>
+                <a:latin typeface="Calibri"/>
+              </a:rPr>
+              <a:t>• Night regression is NOT a fundamental limitation — it is a consequence of a weak Step 1 model</a:t>
+            </a:r>
+          </a:p>
+          <a:p>
+            <a:pPr algn="l">
+              <a:spcAft>
+                <a:spcPts val="600"/>
+              </a:spcAft>
+            </a:pPr>
+            <a:r>
+              <a:rPr sz="1600">
+                <a:solidFill>
+                  <a:srgbClr val="1A1A1A"/>
+                </a:solidFill>
+                <a:latin typeface="Calibri"/>
+              </a:rPr>
+              <a:t>• Sequential UDA factorizes hard domain gaps; Step 1 quality is the primary design lever</a:t>
+            </a:r>
+          </a:p>
+          <a:p>
+            <a:pPr algn="l">
+              <a:spcAft>
+                <a:spcPts val="600"/>
+              </a:spcAft>
+            </a:pPr>
+            <a:r>
+              <a:rPr sz="1600">
+                <a:solidFill>
+                  <a:srgbClr val="1A1A1A"/>
+                </a:solidFill>
+                <a:latin typeface="Calibri"/>
+              </a:rPr>
+              <a:t>• Principle generalises beyond autonomous driving to any multi-hop domain adaptation setting</a:t>
+            </a:r>
+          </a:p>
+        </p:txBody>
+      </p:sp>
+    </p:spTree>
+  </p:cSld>
+  <p:clrMapOvr>
+    <a:masterClrMapping/>
+  </p:clrMapOvr>
+</p:sld>
+</file>
+
+<file path=ppt/slides/slide13.xml><?xml version="1.0" encoding="utf-8"?>
 <p:sld xmlns:a="http://schemas.openxmlformats.org/drawingml/2006/main" xmlns:p="http://schemas.openxmlformats.org/presentationml/2006/main" xmlns:r="http://schemas.openxmlformats.org/officeDocument/2006/relationships">
   <p:cSld>
     <p:spTree>
@@ -10832,7 +12494,7 @@
                 </a:solidFill>
                 <a:latin typeface="Calibri"/>
               </a:rPr>
-              <a:t>Key Finding: The Natural Experiment</a:t>
+              <a:t>Per-Condition Results — Full-Data Pipeline</a:t>
             </a:r>
           </a:p>
         </p:txBody>
@@ -10867,794 +12529,35 @@
                 </a:solidFill>
                 <a:latin typeface="Calibri"/>
               </a:rPr>
-              <a:t>One variable changed — night flips</a:t>
-            </a:r>
-          </a:p>
-        </p:txBody>
-      </p:sp>
-      <p:sp>
-        <p:nvSpPr>
-          <p:cNvPr id="5" name="Rectangle 4"/>
-          <p:cNvSpPr/>
-          <p:nvPr/>
-        </p:nvSpPr>
-        <p:spPr>
-          <a:xfrm>
-            <a:off x="365760" y="1097280"/>
-            <a:ext cx="11430000" cy="914400"/>
-          </a:xfrm>
-          <a:prstGeom prst="rect">
-            <a:avLst/>
-          </a:prstGeom>
-          <a:solidFill>
-            <a:srgbClr val="EEF4FB"/>
-          </a:solidFill>
-          <a:ln w="12700">
-            <a:solidFill>
-              <a:srgbClr val="4C9BE8"/>
-            </a:solidFill>
-          </a:ln>
-        </p:spPr>
-        <p:style>
-          <a:lnRef idx="1">
-            <a:schemeClr val="accent1"/>
-          </a:lnRef>
-          <a:fillRef idx="3">
-            <a:schemeClr val="accent1"/>
-          </a:fillRef>
-          <a:effectRef idx="2">
-            <a:schemeClr val="accent1"/>
-          </a:effectRef>
-          <a:fontRef idx="minor">
-            <a:schemeClr val="lt1"/>
-          </a:fontRef>
-        </p:style>
-        <p:txBody>
-          <a:bodyPr rtlCol="0" anchor="ctr"/>
-          <a:lstStyle/>
-          <a:p>
-            <a:pPr algn="ctr"/>
-          </a:p>
-        </p:txBody>
-      </p:sp>
-      <p:sp>
-        <p:nvSpPr>
-          <p:cNvPr id="6" name="TextBox 5"/>
-          <p:cNvSpPr txBox="1"/>
-          <p:nvPr/>
-        </p:nvSpPr>
-        <p:spPr>
-          <a:xfrm>
-            <a:off x="548640" y="1170432"/>
-            <a:ext cx="11064240" cy="777240"/>
-          </a:xfrm>
-          <a:prstGeom prst="rect">
-            <a:avLst/>
-          </a:prstGeom>
-          <a:noFill/>
-        </p:spPr>
-        <p:txBody>
-          <a:bodyPr wrap="square">
-            <a:spAutoFit/>
-          </a:bodyPr>
-          <a:lstStyle/>
-          <a:p>
-            <a:pPr algn="ctr"/>
-            <a:r>
-              <a:rPr sz="1500" b="0" i="1">
-                <a:solidFill>
-                  <a:srgbClr val="1A4F8A"/>
-                </a:solidFill>
-                <a:latin typeface="Calibri"/>
-              </a:rPr>
-              <a:t>The two runs are identical except for Step 1 dataset size. Everything else — backbone, training procedure, Step 2 config — is the same.</a:t>
-            </a:r>
-          </a:p>
-        </p:txBody>
-      </p:sp>
-      <p:sp>
-        <p:nvSpPr>
-          <p:cNvPr id="7" name="Rectangle 6"/>
-          <p:cNvSpPr/>
-          <p:nvPr/>
-        </p:nvSpPr>
-        <p:spPr>
-          <a:xfrm>
-            <a:off x="365760" y="2194560"/>
-            <a:ext cx="5486400" cy="4297680"/>
-          </a:xfrm>
-          <a:prstGeom prst="rect">
-            <a:avLst/>
-          </a:prstGeom>
-          <a:solidFill>
-            <a:srgbClr val="EEF4FB"/>
-          </a:solidFill>
-          <a:ln w="12700">
-            <a:solidFill>
-              <a:srgbClr val="4C9BE8"/>
-            </a:solidFill>
-          </a:ln>
-        </p:spPr>
-        <p:style>
-          <a:lnRef idx="1">
-            <a:schemeClr val="accent1"/>
-          </a:lnRef>
-          <a:fillRef idx="3">
-            <a:schemeClr val="accent1"/>
-          </a:fillRef>
-          <a:effectRef idx="2">
-            <a:schemeClr val="accent1"/>
-          </a:effectRef>
-          <a:fontRef idx="minor">
-            <a:schemeClr val="lt1"/>
-          </a:fontRef>
-        </p:style>
-        <p:txBody>
-          <a:bodyPr rtlCol="0" anchor="ctr"/>
-          <a:lstStyle/>
-          <a:p>
-            <a:pPr algn="ctr"/>
-          </a:p>
-        </p:txBody>
-      </p:sp>
-      <p:sp>
-        <p:nvSpPr>
-          <p:cNvPr id="8" name="TextBox 7"/>
-          <p:cNvSpPr txBox="1"/>
-          <p:nvPr/>
-        </p:nvSpPr>
-        <p:spPr>
-          <a:xfrm>
-            <a:off x="502920" y="2286000"/>
-            <a:ext cx="5212080" cy="365760"/>
-          </a:xfrm>
-          <a:prstGeom prst="rect">
-            <a:avLst/>
-          </a:prstGeom>
-          <a:noFill/>
-        </p:spPr>
-        <p:txBody>
-          <a:bodyPr wrap="square">
-            <a:spAutoFit/>
-          </a:bodyPr>
-          <a:lstStyle/>
-          <a:p>
-            <a:pPr algn="l"/>
-            <a:r>
-              <a:rPr sz="1600" b="1" i="0">
-                <a:solidFill>
-                  <a:srgbClr val="1A4F8A"/>
-                </a:solidFill>
-                <a:latin typeface="Calibri"/>
-              </a:rPr>
-              <a:t>Partial-data</a:t>
-            </a:r>
-          </a:p>
-        </p:txBody>
-      </p:sp>
-      <p:sp>
-        <p:nvSpPr>
-          <p:cNvPr id="9" name="TextBox 8"/>
-          <p:cNvSpPr txBox="1"/>
-          <p:nvPr/>
-        </p:nvSpPr>
-        <p:spPr>
-          <a:xfrm>
-            <a:off x="502920" y="2697480"/>
-            <a:ext cx="5212080" cy="457200"/>
-          </a:xfrm>
-          <a:prstGeom prst="rect">
-            <a:avLst/>
-          </a:prstGeom>
-          <a:noFill/>
-        </p:spPr>
-        <p:txBody>
-          <a:bodyPr wrap="square">
-            <a:spAutoFit/>
-          </a:bodyPr>
-          <a:lstStyle/>
-          <a:p>
-            <a:pPr algn="l"/>
-            <a:r>
-              <a:rPr sz="1300" b="0" i="0">
-                <a:solidFill>
-                  <a:srgbClr val="555555"/>
-                </a:solidFill>
-                <a:latin typeface="Calibri"/>
-              </a:rPr>
-              <a:t>Step 1: 30.30% CS val
-(~10K GTA5 pairs)</a:t>
-            </a:r>
-          </a:p>
-        </p:txBody>
-      </p:sp>
-      <p:sp>
-        <p:nvSpPr>
-          <p:cNvPr id="10" name="TextBox 9"/>
-          <p:cNvSpPr txBox="1"/>
-          <p:nvPr/>
-        </p:nvSpPr>
-        <p:spPr>
-          <a:xfrm>
-            <a:off x="502920" y="3200400"/>
-            <a:ext cx="2286000" cy="320040"/>
-          </a:xfrm>
-          <a:prstGeom prst="rect">
-            <a:avLst/>
-          </a:prstGeom>
-          <a:noFill/>
-        </p:spPr>
-        <p:txBody>
-          <a:bodyPr wrap="square">
-            <a:spAutoFit/>
-          </a:bodyPr>
-          <a:lstStyle/>
-          <a:p>
-            <a:pPr algn="l"/>
-            <a:r>
-              <a:rPr sz="1200" b="1" i="0">
-                <a:solidFill>
-                  <a:srgbClr val="1A1A1A"/>
-                </a:solidFill>
-                <a:latin typeface="Calibri"/>
-              </a:rPr>
-              <a:t>Night Before:</a:t>
-            </a:r>
-          </a:p>
-        </p:txBody>
-      </p:sp>
-      <p:sp>
-        <p:nvSpPr>
-          <p:cNvPr id="11" name="TextBox 10"/>
-          <p:cNvSpPr txBox="1"/>
-          <p:nvPr/>
-        </p:nvSpPr>
-        <p:spPr>
-          <a:xfrm>
-            <a:off x="2834640" y="3200400"/>
-            <a:ext cx="2743200" cy="320040"/>
-          </a:xfrm>
-          <a:prstGeom prst="rect">
-            <a:avLst/>
-          </a:prstGeom>
-          <a:noFill/>
-        </p:spPr>
-        <p:txBody>
-          <a:bodyPr wrap="square">
-            <a:spAutoFit/>
-          </a:bodyPr>
-          <a:lstStyle/>
-          <a:p>
-            <a:pPr algn="l"/>
-            <a:r>
-              <a:rPr sz="1400" b="1" i="0">
-                <a:solidFill>
-                  <a:srgbClr val="E8A23C"/>
-                </a:solidFill>
-                <a:latin typeface="Calibri"/>
-              </a:rPr>
-              <a:t>11.5%</a:t>
-            </a:r>
-          </a:p>
-        </p:txBody>
-      </p:sp>
-      <p:sp>
-        <p:nvSpPr>
-          <p:cNvPr id="12" name="TextBox 11"/>
-          <p:cNvSpPr txBox="1"/>
-          <p:nvPr/>
-        </p:nvSpPr>
-        <p:spPr>
-          <a:xfrm>
-            <a:off x="502920" y="3566160"/>
-            <a:ext cx="2286000" cy="320040"/>
-          </a:xfrm>
-          <a:prstGeom prst="rect">
-            <a:avLst/>
-          </a:prstGeom>
-          <a:noFill/>
-        </p:spPr>
-        <p:txBody>
-          <a:bodyPr wrap="square">
-            <a:spAutoFit/>
-          </a:bodyPr>
-          <a:lstStyle/>
-          <a:p>
-            <a:pPr algn="l"/>
-            <a:r>
-              <a:rPr sz="1200" b="1" i="0">
-                <a:solidFill>
-                  <a:srgbClr val="1A1A1A"/>
-                </a:solidFill>
-                <a:latin typeface="Calibri"/>
-              </a:rPr>
-              <a:t>Night After:</a:t>
-            </a:r>
-          </a:p>
-        </p:txBody>
-      </p:sp>
-      <p:sp>
-        <p:nvSpPr>
-          <p:cNvPr id="13" name="TextBox 12"/>
-          <p:cNvSpPr txBox="1"/>
-          <p:nvPr/>
-        </p:nvSpPr>
-        <p:spPr>
-          <a:xfrm>
-            <a:off x="2834640" y="3566160"/>
-            <a:ext cx="2743200" cy="320040"/>
-          </a:xfrm>
-          <a:prstGeom prst="rect">
-            <a:avLst/>
-          </a:prstGeom>
-          <a:noFill/>
-        </p:spPr>
-        <p:txBody>
-          <a:bodyPr wrap="square">
-            <a:spAutoFit/>
-          </a:bodyPr>
-          <a:lstStyle/>
-          <a:p>
-            <a:pPr algn="l"/>
-            <a:r>
-              <a:rPr sz="1400" b="1" i="0">
-                <a:solidFill>
-                  <a:srgbClr val="E8A23C"/>
-                </a:solidFill>
-                <a:latin typeface="Calibri"/>
-              </a:rPr>
-              <a:t>8.4%</a:t>
-            </a:r>
-          </a:p>
-        </p:txBody>
-      </p:sp>
-      <p:sp>
-        <p:nvSpPr>
-          <p:cNvPr id="14" name="Rectangle 13"/>
-          <p:cNvSpPr/>
-          <p:nvPr/>
-        </p:nvSpPr>
-        <p:spPr>
-          <a:xfrm>
-            <a:off x="502920" y="4023360"/>
-            <a:ext cx="5029200" cy="502920"/>
-          </a:xfrm>
-          <a:prstGeom prst="rect">
-            <a:avLst/>
-          </a:prstGeom>
-          <a:solidFill>
-            <a:srgbClr val="1A4F8A"/>
-          </a:solidFill>
-          <a:ln>
-            <a:noFill/>
-          </a:ln>
-        </p:spPr>
-        <p:style>
-          <a:lnRef idx="1">
-            <a:schemeClr val="accent1"/>
-          </a:lnRef>
-          <a:fillRef idx="3">
-            <a:schemeClr val="accent1"/>
-          </a:fillRef>
-          <a:effectRef idx="2">
-            <a:schemeClr val="accent1"/>
-          </a:effectRef>
-          <a:fontRef idx="minor">
-            <a:schemeClr val="lt1"/>
-          </a:fontRef>
-        </p:style>
-        <p:txBody>
-          <a:bodyPr rtlCol="0" anchor="ctr"/>
-          <a:lstStyle/>
-          <a:p>
-            <a:pPr algn="ctr"/>
-          </a:p>
-        </p:txBody>
-      </p:sp>
-      <p:sp>
-        <p:nvSpPr>
-          <p:cNvPr id="15" name="TextBox 14"/>
-          <p:cNvSpPr txBox="1"/>
-          <p:nvPr/>
-        </p:nvSpPr>
-        <p:spPr>
-          <a:xfrm>
-            <a:off x="502920" y="4023360"/>
-            <a:ext cx="5029200" cy="502920"/>
-          </a:xfrm>
-          <a:prstGeom prst="rect">
-            <a:avLst/>
-          </a:prstGeom>
-          <a:noFill/>
-        </p:spPr>
-        <p:txBody>
-          <a:bodyPr wrap="square">
-            <a:spAutoFit/>
-          </a:bodyPr>
-          <a:lstStyle/>
-          <a:p>
-            <a:pPr algn="ctr"/>
-            <a:r>
-              <a:rPr sz="1600" b="1" i="0">
-                <a:solidFill>
-                  <a:srgbClr val="C0392B"/>
-                </a:solidFill>
-                <a:latin typeface="Calibri"/>
-              </a:rPr>
-              <a:t>−3.1 pp  REGRESSION</a:t>
-            </a:r>
-          </a:p>
-        </p:txBody>
-      </p:sp>
-      <p:sp>
-        <p:nvSpPr>
-          <p:cNvPr id="16" name="Rectangle 15"/>
-          <p:cNvSpPr/>
-          <p:nvPr/>
-        </p:nvSpPr>
-        <p:spPr>
-          <a:xfrm>
-            <a:off x="6217920" y="2194560"/>
-            <a:ext cx="5486400" cy="4297680"/>
-          </a:xfrm>
-          <a:prstGeom prst="rect">
-            <a:avLst/>
-          </a:prstGeom>
-          <a:solidFill>
-            <a:srgbClr val="EEF4FB"/>
-          </a:solidFill>
-          <a:ln w="12700">
-            <a:solidFill>
-              <a:srgbClr val="4C9BE8"/>
-            </a:solidFill>
-          </a:ln>
-        </p:spPr>
-        <p:style>
-          <a:lnRef idx="1">
-            <a:schemeClr val="accent1"/>
-          </a:lnRef>
-          <a:fillRef idx="3">
-            <a:schemeClr val="accent1"/>
-          </a:fillRef>
-          <a:effectRef idx="2">
-            <a:schemeClr val="accent1"/>
-          </a:effectRef>
-          <a:fontRef idx="minor">
-            <a:schemeClr val="lt1"/>
-          </a:fontRef>
-        </p:style>
-        <p:txBody>
-          <a:bodyPr rtlCol="0" anchor="ctr"/>
-          <a:lstStyle/>
-          <a:p>
-            <a:pPr algn="ctr"/>
-          </a:p>
-        </p:txBody>
-      </p:sp>
-      <p:sp>
-        <p:nvSpPr>
-          <p:cNvPr id="17" name="TextBox 16"/>
-          <p:cNvSpPr txBox="1"/>
-          <p:nvPr/>
-        </p:nvSpPr>
-        <p:spPr>
-          <a:xfrm>
-            <a:off x="6355080" y="2286000"/>
-            <a:ext cx="5212080" cy="365760"/>
-          </a:xfrm>
-          <a:prstGeom prst="rect">
-            <a:avLst/>
-          </a:prstGeom>
-          <a:noFill/>
-        </p:spPr>
-        <p:txBody>
-          <a:bodyPr wrap="square">
-            <a:spAutoFit/>
-          </a:bodyPr>
-          <a:lstStyle/>
-          <a:p>
-            <a:pPr algn="l"/>
-            <a:r>
-              <a:rPr sz="1600" b="1" i="0">
-                <a:solidFill>
-                  <a:srgbClr val="1A4F8A"/>
-                </a:solidFill>
-                <a:latin typeface="Calibri"/>
-              </a:rPr>
-              <a:t>Full-data</a:t>
-            </a:r>
-          </a:p>
-        </p:txBody>
-      </p:sp>
-      <p:sp>
-        <p:nvSpPr>
-          <p:cNvPr id="18" name="TextBox 17"/>
-          <p:cNvSpPr txBox="1"/>
-          <p:nvPr/>
-        </p:nvSpPr>
-        <p:spPr>
-          <a:xfrm>
-            <a:off x="6355080" y="2697480"/>
-            <a:ext cx="5212080" cy="457200"/>
-          </a:xfrm>
-          <a:prstGeom prst="rect">
-            <a:avLst/>
-          </a:prstGeom>
-          <a:noFill/>
-        </p:spPr>
-        <p:txBody>
-          <a:bodyPr wrap="square">
-            <a:spAutoFit/>
-          </a:bodyPr>
-          <a:lstStyle/>
-          <a:p>
-            <a:pPr algn="l"/>
-            <a:r>
-              <a:rPr sz="1300" b="0" i="0">
-                <a:solidFill>
-                  <a:srgbClr val="555555"/>
-                </a:solidFill>
-                <a:latin typeface="Calibri"/>
-              </a:rPr>
-              <a:t>Step 1: 38.90% CS val
-(24,966 GTA5 pairs)</a:t>
-            </a:r>
-          </a:p>
-        </p:txBody>
-      </p:sp>
-      <p:sp>
-        <p:nvSpPr>
-          <p:cNvPr id="19" name="TextBox 18"/>
-          <p:cNvSpPr txBox="1"/>
-          <p:nvPr/>
-        </p:nvSpPr>
-        <p:spPr>
-          <a:xfrm>
-            <a:off x="6355080" y="3200400"/>
-            <a:ext cx="2286000" cy="320040"/>
-          </a:xfrm>
-          <a:prstGeom prst="rect">
-            <a:avLst/>
-          </a:prstGeom>
-          <a:noFill/>
-        </p:spPr>
-        <p:txBody>
-          <a:bodyPr wrap="square">
-            <a:spAutoFit/>
-          </a:bodyPr>
-          <a:lstStyle/>
-          <a:p>
-            <a:pPr algn="l"/>
-            <a:r>
-              <a:rPr sz="1200" b="1" i="0">
-                <a:solidFill>
-                  <a:srgbClr val="1A1A1A"/>
-                </a:solidFill>
-                <a:latin typeface="Calibri"/>
-              </a:rPr>
-              <a:t>Night Before:</a:t>
-            </a:r>
-          </a:p>
-        </p:txBody>
-      </p:sp>
-      <p:sp>
-        <p:nvSpPr>
-          <p:cNvPr id="20" name="TextBox 19"/>
-          <p:cNvSpPr txBox="1"/>
-          <p:nvPr/>
-        </p:nvSpPr>
-        <p:spPr>
-          <a:xfrm>
-            <a:off x="8686800" y="3200400"/>
-            <a:ext cx="2743200" cy="320040"/>
-          </a:xfrm>
-          <a:prstGeom prst="rect">
-            <a:avLst/>
-          </a:prstGeom>
-          <a:noFill/>
-        </p:spPr>
-        <p:txBody>
-          <a:bodyPr wrap="square">
-            <a:spAutoFit/>
-          </a:bodyPr>
-          <a:lstStyle/>
-          <a:p>
-            <a:pPr algn="l"/>
-            <a:r>
-              <a:rPr sz="1400" b="1" i="0">
-                <a:solidFill>
-                  <a:srgbClr val="E8A23C"/>
-                </a:solidFill>
-                <a:latin typeface="Calibri"/>
-              </a:rPr>
-              <a:t>15.02%</a:t>
-            </a:r>
-          </a:p>
-        </p:txBody>
-      </p:sp>
-      <p:sp>
-        <p:nvSpPr>
-          <p:cNvPr id="21" name="TextBox 20"/>
-          <p:cNvSpPr txBox="1"/>
-          <p:nvPr/>
-        </p:nvSpPr>
-        <p:spPr>
-          <a:xfrm>
-            <a:off x="6355080" y="3566160"/>
-            <a:ext cx="2286000" cy="320040"/>
-          </a:xfrm>
-          <a:prstGeom prst="rect">
-            <a:avLst/>
-          </a:prstGeom>
-          <a:noFill/>
-        </p:spPr>
-        <p:txBody>
-          <a:bodyPr wrap="square">
-            <a:spAutoFit/>
-          </a:bodyPr>
-          <a:lstStyle/>
-          <a:p>
-            <a:pPr algn="l"/>
-            <a:r>
-              <a:rPr sz="1200" b="1" i="0">
-                <a:solidFill>
-                  <a:srgbClr val="1A1A1A"/>
-                </a:solidFill>
-                <a:latin typeface="Calibri"/>
-              </a:rPr>
-              <a:t>Night After:</a:t>
-            </a:r>
-          </a:p>
-        </p:txBody>
-      </p:sp>
-      <p:sp>
-        <p:nvSpPr>
-          <p:cNvPr id="22" name="TextBox 21"/>
-          <p:cNvSpPr txBox="1"/>
-          <p:nvPr/>
-        </p:nvSpPr>
-        <p:spPr>
-          <a:xfrm>
-            <a:off x="8686800" y="3566160"/>
-            <a:ext cx="2743200" cy="320040"/>
-          </a:xfrm>
-          <a:prstGeom prst="rect">
-            <a:avLst/>
-          </a:prstGeom>
-          <a:noFill/>
-        </p:spPr>
-        <p:txBody>
-          <a:bodyPr wrap="square">
-            <a:spAutoFit/>
-          </a:bodyPr>
-          <a:lstStyle/>
-          <a:p>
-            <a:pPr algn="l"/>
-            <a:r>
-              <a:rPr sz="1400" b="1" i="0">
-                <a:solidFill>
-                  <a:srgbClr val="E8A23C"/>
-                </a:solidFill>
-                <a:latin typeface="Calibri"/>
-              </a:rPr>
-              <a:t>16.77%</a:t>
-            </a:r>
-          </a:p>
-        </p:txBody>
-      </p:sp>
-      <p:sp>
-        <p:nvSpPr>
-          <p:cNvPr id="23" name="Rectangle 22"/>
-          <p:cNvSpPr/>
-          <p:nvPr/>
-        </p:nvSpPr>
-        <p:spPr>
-          <a:xfrm>
-            <a:off x="6355080" y="4023360"/>
-            <a:ext cx="5029200" cy="502920"/>
-          </a:xfrm>
-          <a:prstGeom prst="rect">
-            <a:avLst/>
-          </a:prstGeom>
-          <a:solidFill>
-            <a:srgbClr val="1A4F8A"/>
-          </a:solidFill>
-          <a:ln>
-            <a:noFill/>
-          </a:ln>
-        </p:spPr>
-        <p:style>
-          <a:lnRef idx="1">
-            <a:schemeClr val="accent1"/>
-          </a:lnRef>
-          <a:fillRef idx="3">
-            <a:schemeClr val="accent1"/>
-          </a:fillRef>
-          <a:effectRef idx="2">
-            <a:schemeClr val="accent1"/>
-          </a:effectRef>
-          <a:fontRef idx="minor">
-            <a:schemeClr val="lt1"/>
-          </a:fontRef>
-        </p:style>
-        <p:txBody>
-          <a:bodyPr rtlCol="0" anchor="ctr"/>
-          <a:lstStyle/>
-          <a:p>
-            <a:pPr algn="ctr"/>
-          </a:p>
-        </p:txBody>
-      </p:sp>
-      <p:sp>
-        <p:nvSpPr>
-          <p:cNvPr id="24" name="TextBox 23"/>
-          <p:cNvSpPr txBox="1"/>
-          <p:nvPr/>
-        </p:nvSpPr>
-        <p:spPr>
-          <a:xfrm>
-            <a:off x="6355080" y="4023360"/>
-            <a:ext cx="5029200" cy="502920"/>
-          </a:xfrm>
-          <a:prstGeom prst="rect">
-            <a:avLst/>
-          </a:prstGeom>
-          <a:noFill/>
-        </p:spPr>
-        <p:txBody>
-          <a:bodyPr wrap="square">
-            <a:spAutoFit/>
-          </a:bodyPr>
-          <a:lstStyle/>
-          <a:p>
-            <a:pPr algn="ctr"/>
-            <a:r>
-              <a:rPr sz="1600" b="1" i="0">
-                <a:solidFill>
-                  <a:srgbClr val="27AE60"/>
-                </a:solidFill>
-                <a:latin typeface="Calibri"/>
-              </a:rPr>
-              <a:t>+1.74 pp  IMPROVEMENT</a:t>
-            </a:r>
-          </a:p>
-        </p:txBody>
-      </p:sp>
-      <p:sp>
-        <p:nvSpPr>
-          <p:cNvPr id="25" name="TextBox 24"/>
-          <p:cNvSpPr txBox="1"/>
-          <p:nvPr/>
-        </p:nvSpPr>
-        <p:spPr>
-          <a:xfrm>
-            <a:off x="365760" y="6400800"/>
-            <a:ext cx="11430000" cy="365760"/>
-          </a:xfrm>
-          <a:prstGeom prst="rect">
-            <a:avLst/>
-          </a:prstGeom>
-          <a:noFill/>
-        </p:spPr>
-        <p:txBody>
-          <a:bodyPr wrap="square">
-            <a:spAutoFit/>
-          </a:bodyPr>
-          <a:lstStyle/>
-          <a:p>
-            <a:pPr algn="ctr"/>
-            <a:r>
-              <a:rPr sz="1400" b="1" i="0">
-                <a:solidFill>
-                  <a:srgbClr val="1A4F8A"/>
-                </a:solidFill>
-                <a:latin typeface="Calibri"/>
-              </a:rPr>
-              <a:t>→  Step 1 quality is the causal mechanism for night adaptation, not the method itself.</a:t>
-            </a:r>
-          </a:p>
-        </p:txBody>
-      </p:sp>
+              <a:t>Before vs. After Step 2 — 24,966 GTA5 pairs, Step 1: 38.90% CS val</a:t>
+            </a:r>
+          </a:p>
+        </p:txBody>
+      </p:sp>
+      <p:pic>
+        <p:nvPicPr>
+          <p:cNvPr id="5" name="Picture 4" descr="fig_before_after_bar_full.png"/>
+          <p:cNvPicPr>
+            <a:picLocks noChangeAspect="1"/>
+          </p:cNvPicPr>
+          <p:nvPr/>
+        </p:nvPicPr>
+        <p:blipFill>
+          <a:blip r:embed="rId2"/>
+          <a:stretch>
+            <a:fillRect/>
+          </a:stretch>
+        </p:blipFill>
+        <p:spPr>
+          <a:xfrm>
+            <a:off x="1371600" y="1097280"/>
+            <a:ext cx="9418320" cy="5886450"/>
+          </a:xfrm>
+          <a:prstGeom prst="rect">
+            <a:avLst/>
+          </a:prstGeom>
+        </p:spPr>
+      </p:pic>
     </p:spTree>
   </p:cSld>
   <p:clrMapOvr>
@@ -11746,7 +12649,7 @@
                 </a:solidFill>
                 <a:latin typeface="Calibri"/>
               </a:rPr>
-              <a:t>Broader Applicability</a:t>
+              <a:t>Step 2 Adaptation Curve — Full-Data Pipeline</a:t>
             </a:r>
           </a:p>
         </p:txBody>
@@ -11781,626 +12684,35 @@
                 </a:solidFill>
                 <a:latin typeface="Calibri"/>
               </a:rPr>
-              <a:t>The principle extends beyond autonomous driving</a:t>
-            </a:r>
-          </a:p>
-        </p:txBody>
-      </p:sp>
-      <p:sp>
-        <p:nvSpPr>
-          <p:cNvPr id="5" name="TextBox 4"/>
-          <p:cNvSpPr txBox="1"/>
-          <p:nvPr/>
-        </p:nvSpPr>
-        <p:spPr>
-          <a:xfrm>
-            <a:off x="365760" y="1097280"/>
-            <a:ext cx="11430000" cy="457200"/>
-          </a:xfrm>
-          <a:prstGeom prst="rect">
-            <a:avLst/>
-          </a:prstGeom>
-          <a:noFill/>
-        </p:spPr>
-        <p:txBody>
-          <a:bodyPr wrap="square">
-            <a:spAutoFit/>
-          </a:bodyPr>
-          <a:lstStyle/>
-          <a:p>
-            <a:pPr algn="l"/>
-            <a:r>
-              <a:rPr sz="1500" b="0" i="0">
-                <a:solidFill>
-                  <a:srgbClr val="1A1A1A"/>
-                </a:solidFill>
-                <a:latin typeface="Calibri"/>
-              </a:rPr>
-              <a:t>Two-step UDA applies whenever a large domain gap can be factored through a labeled intermediate domain:</a:t>
-            </a:r>
-          </a:p>
-        </p:txBody>
-      </p:sp>
-      <p:sp>
-        <p:nvSpPr>
-          <p:cNvPr id="6" name="Rectangle 5"/>
-          <p:cNvSpPr/>
-          <p:nvPr/>
-        </p:nvSpPr>
-        <p:spPr>
-          <a:xfrm>
-            <a:off x="457200" y="1691640"/>
-            <a:ext cx="2468880" cy="2560320"/>
-          </a:xfrm>
-          <a:prstGeom prst="rect">
-            <a:avLst/>
-          </a:prstGeom>
-          <a:solidFill>
-            <a:srgbClr val="1A4F8A"/>
-          </a:solidFill>
-          <a:ln>
-            <a:noFill/>
-          </a:ln>
-        </p:spPr>
-        <p:style>
-          <a:lnRef idx="1">
-            <a:schemeClr val="accent1"/>
-          </a:lnRef>
-          <a:fillRef idx="3">
-            <a:schemeClr val="accent1"/>
-          </a:fillRef>
-          <a:effectRef idx="2">
-            <a:schemeClr val="accent1"/>
-          </a:effectRef>
-          <a:fontRef idx="minor">
-            <a:schemeClr val="lt1"/>
-          </a:fontRef>
-        </p:style>
-        <p:txBody>
-          <a:bodyPr rtlCol="0" anchor="ctr"/>
-          <a:lstStyle/>
-          <a:p>
-            <a:pPr algn="ctr"/>
-          </a:p>
-        </p:txBody>
-      </p:sp>
-      <p:sp>
-        <p:nvSpPr>
-          <p:cNvPr id="7" name="TextBox 6"/>
-          <p:cNvSpPr txBox="1"/>
-          <p:nvPr/>
-        </p:nvSpPr>
-        <p:spPr>
-          <a:xfrm>
-            <a:off x="457200" y="1691640"/>
-            <a:ext cx="2468880" cy="685800"/>
-          </a:xfrm>
-          <a:prstGeom prst="rect">
-            <a:avLst/>
-          </a:prstGeom>
-          <a:noFill/>
-        </p:spPr>
-        <p:txBody>
-          <a:bodyPr wrap="square">
-            <a:spAutoFit/>
-          </a:bodyPr>
-          <a:lstStyle/>
-          <a:p>
-            <a:pPr algn="ctr"/>
-            <a:r>
-              <a:rPr sz="1400" b="1" i="0">
-                <a:solidFill>
-                  <a:srgbClr val="FFFFFF"/>
-                </a:solidFill>
-                <a:latin typeface="Calibri"/>
-              </a:rPr>
-              <a:t>Autonomous
-Driving</a:t>
-            </a:r>
-          </a:p>
-        </p:txBody>
-      </p:sp>
-      <p:sp>
-        <p:nvSpPr>
-          <p:cNvPr id="8" name="TextBox 7"/>
-          <p:cNvSpPr txBox="1"/>
-          <p:nvPr/>
-        </p:nvSpPr>
-        <p:spPr>
-          <a:xfrm>
-            <a:off x="548640" y="2423160"/>
-            <a:ext cx="2286000" cy="1737360"/>
-          </a:xfrm>
-          <a:prstGeom prst="rect">
-            <a:avLst/>
-          </a:prstGeom>
-          <a:noFill/>
-        </p:spPr>
-        <p:txBody>
-          <a:bodyPr wrap="square">
-            <a:spAutoFit/>
-          </a:bodyPr>
-          <a:lstStyle/>
-          <a:p>
-            <a:pPr algn="ctr"/>
-            <a:r>
-              <a:rPr sz="1200" b="0" i="0">
-                <a:solidFill>
-                  <a:srgbClr val="4C9BE8"/>
-                </a:solidFill>
-                <a:latin typeface="Calibri"/>
-              </a:rPr>
-              <a:t>Synthetic game data
-→ Clean real scenes
-→ Adverse weather</a:t>
-            </a:r>
-          </a:p>
-        </p:txBody>
-      </p:sp>
-      <p:sp>
-        <p:nvSpPr>
-          <p:cNvPr id="9" name="Rectangle 8"/>
-          <p:cNvSpPr/>
-          <p:nvPr/>
-        </p:nvSpPr>
-        <p:spPr>
-          <a:xfrm>
-            <a:off x="3200400" y="1691640"/>
-            <a:ext cx="2468880" cy="2560320"/>
-          </a:xfrm>
-          <a:prstGeom prst="rect">
-            <a:avLst/>
-          </a:prstGeom>
-          <a:solidFill>
-            <a:srgbClr val="1A4F8A"/>
-          </a:solidFill>
-          <a:ln>
-            <a:noFill/>
-          </a:ln>
-        </p:spPr>
-        <p:style>
-          <a:lnRef idx="1">
-            <a:schemeClr val="accent1"/>
-          </a:lnRef>
-          <a:fillRef idx="3">
-            <a:schemeClr val="accent1"/>
-          </a:fillRef>
-          <a:effectRef idx="2">
-            <a:schemeClr val="accent1"/>
-          </a:effectRef>
-          <a:fontRef idx="minor">
-            <a:schemeClr val="lt1"/>
-          </a:fontRef>
-        </p:style>
-        <p:txBody>
-          <a:bodyPr rtlCol="0" anchor="ctr"/>
-          <a:lstStyle/>
-          <a:p>
-            <a:pPr algn="ctr"/>
-          </a:p>
-        </p:txBody>
-      </p:sp>
-      <p:sp>
-        <p:nvSpPr>
-          <p:cNvPr id="10" name="TextBox 9"/>
-          <p:cNvSpPr txBox="1"/>
-          <p:nvPr/>
-        </p:nvSpPr>
-        <p:spPr>
-          <a:xfrm>
-            <a:off x="3200400" y="1691640"/>
-            <a:ext cx="2468880" cy="685800"/>
-          </a:xfrm>
-          <a:prstGeom prst="rect">
-            <a:avLst/>
-          </a:prstGeom>
-          <a:noFill/>
-        </p:spPr>
-        <p:txBody>
-          <a:bodyPr wrap="square">
-            <a:spAutoFit/>
-          </a:bodyPr>
-          <a:lstStyle/>
-          <a:p>
-            <a:pPr algn="ctr"/>
-            <a:r>
-              <a:rPr sz="1400" b="1" i="0">
-                <a:solidFill>
-                  <a:srgbClr val="FFFFFF"/>
-                </a:solidFill>
-                <a:latin typeface="Calibri"/>
-              </a:rPr>
-              <a:t>Medical
-Imaging</a:t>
-            </a:r>
-          </a:p>
-        </p:txBody>
-      </p:sp>
-      <p:sp>
-        <p:nvSpPr>
-          <p:cNvPr id="11" name="TextBox 10"/>
-          <p:cNvSpPr txBox="1"/>
-          <p:nvPr/>
-        </p:nvSpPr>
-        <p:spPr>
-          <a:xfrm>
-            <a:off x="3291840" y="2423160"/>
-            <a:ext cx="2286000" cy="1737360"/>
-          </a:xfrm>
-          <a:prstGeom prst="rect">
-            <a:avLst/>
-          </a:prstGeom>
-          <a:noFill/>
-        </p:spPr>
-        <p:txBody>
-          <a:bodyPr wrap="square">
-            <a:spAutoFit/>
-          </a:bodyPr>
-          <a:lstStyle/>
-          <a:p>
-            <a:pPr algn="ctr"/>
-            <a:r>
-              <a:rPr sz="1200" b="0" i="0">
-                <a:solidFill>
-                  <a:srgbClr val="4C9BE8"/>
-                </a:solidFill>
-                <a:latin typeface="Calibri"/>
-              </a:rPr>
-              <a:t>Synthetic scans
-→ One scanner type
-→ Noisier scanner</a:t>
-            </a:r>
-          </a:p>
-        </p:txBody>
-      </p:sp>
-      <p:sp>
-        <p:nvSpPr>
-          <p:cNvPr id="12" name="Rectangle 11"/>
-          <p:cNvSpPr/>
-          <p:nvPr/>
-        </p:nvSpPr>
-        <p:spPr>
-          <a:xfrm>
-            <a:off x="5943600" y="1691640"/>
-            <a:ext cx="2468880" cy="2560320"/>
-          </a:xfrm>
-          <a:prstGeom prst="rect">
-            <a:avLst/>
-          </a:prstGeom>
-          <a:solidFill>
-            <a:srgbClr val="1A4F8A"/>
-          </a:solidFill>
-          <a:ln>
-            <a:noFill/>
-          </a:ln>
-        </p:spPr>
-        <p:style>
-          <a:lnRef idx="1">
-            <a:schemeClr val="accent1"/>
-          </a:lnRef>
-          <a:fillRef idx="3">
-            <a:schemeClr val="accent1"/>
-          </a:fillRef>
-          <a:effectRef idx="2">
-            <a:schemeClr val="accent1"/>
-          </a:effectRef>
-          <a:fontRef idx="minor">
-            <a:schemeClr val="lt1"/>
-          </a:fontRef>
-        </p:style>
-        <p:txBody>
-          <a:bodyPr rtlCol="0" anchor="ctr"/>
-          <a:lstStyle/>
-          <a:p>
-            <a:pPr algn="ctr"/>
-          </a:p>
-        </p:txBody>
-      </p:sp>
-      <p:sp>
-        <p:nvSpPr>
-          <p:cNvPr id="13" name="TextBox 12"/>
-          <p:cNvSpPr txBox="1"/>
-          <p:nvPr/>
-        </p:nvSpPr>
-        <p:spPr>
-          <a:xfrm>
-            <a:off x="5943600" y="1691640"/>
-            <a:ext cx="2468880" cy="685800"/>
-          </a:xfrm>
-          <a:prstGeom prst="rect">
-            <a:avLst/>
-          </a:prstGeom>
-          <a:noFill/>
-        </p:spPr>
-        <p:txBody>
-          <a:bodyPr wrap="square">
-            <a:spAutoFit/>
-          </a:bodyPr>
-          <a:lstStyle/>
-          <a:p>
-            <a:pPr algn="ctr"/>
-            <a:r>
-              <a:rPr sz="1400" b="1" i="0">
-                <a:solidFill>
-                  <a:srgbClr val="FFFFFF"/>
-                </a:solidFill>
-                <a:latin typeface="Calibri"/>
-              </a:rPr>
-              <a:t>Satellite
-Imagery</a:t>
-            </a:r>
-          </a:p>
-        </p:txBody>
-      </p:sp>
-      <p:sp>
-        <p:nvSpPr>
-          <p:cNvPr id="14" name="TextBox 13"/>
-          <p:cNvSpPr txBox="1"/>
-          <p:nvPr/>
-        </p:nvSpPr>
-        <p:spPr>
-          <a:xfrm>
-            <a:off x="6035040" y="2423160"/>
-            <a:ext cx="2286000" cy="1737360"/>
-          </a:xfrm>
-          <a:prstGeom prst="rect">
-            <a:avLst/>
-          </a:prstGeom>
-          <a:noFill/>
-        </p:spPr>
-        <p:txBody>
-          <a:bodyPr wrap="square">
-            <a:spAutoFit/>
-          </a:bodyPr>
-          <a:lstStyle/>
-          <a:p>
-            <a:pPr algn="ctr"/>
-            <a:r>
-              <a:rPr sz="1200" b="0" i="0">
-                <a:solidFill>
-                  <a:srgbClr val="4C9BE8"/>
-                </a:solidFill>
-                <a:latin typeface="Calibri"/>
-              </a:rPr>
-              <a:t>One season/region
-→ Intermediate domain
-→ Target region</a:t>
-            </a:r>
-          </a:p>
-        </p:txBody>
-      </p:sp>
-      <p:sp>
-        <p:nvSpPr>
-          <p:cNvPr id="15" name="Rectangle 14"/>
-          <p:cNvSpPr/>
-          <p:nvPr/>
-        </p:nvSpPr>
-        <p:spPr>
-          <a:xfrm>
-            <a:off x="8686800" y="1691640"/>
-            <a:ext cx="2468880" cy="2560320"/>
-          </a:xfrm>
-          <a:prstGeom prst="rect">
-            <a:avLst/>
-          </a:prstGeom>
-          <a:solidFill>
-            <a:srgbClr val="1A4F8A"/>
-          </a:solidFill>
-          <a:ln>
-            <a:noFill/>
-          </a:ln>
-        </p:spPr>
-        <p:style>
-          <a:lnRef idx="1">
-            <a:schemeClr val="accent1"/>
-          </a:lnRef>
-          <a:fillRef idx="3">
-            <a:schemeClr val="accent1"/>
-          </a:fillRef>
-          <a:effectRef idx="2">
-            <a:schemeClr val="accent1"/>
-          </a:effectRef>
-          <a:fontRef idx="minor">
-            <a:schemeClr val="lt1"/>
-          </a:fontRef>
-        </p:style>
-        <p:txBody>
-          <a:bodyPr rtlCol="0" anchor="ctr"/>
-          <a:lstStyle/>
-          <a:p>
-            <a:pPr algn="ctr"/>
-          </a:p>
-        </p:txBody>
-      </p:sp>
-      <p:sp>
-        <p:nvSpPr>
-          <p:cNvPr id="16" name="TextBox 15"/>
-          <p:cNvSpPr txBox="1"/>
-          <p:nvPr/>
-        </p:nvSpPr>
-        <p:spPr>
-          <a:xfrm>
-            <a:off x="8686800" y="1691640"/>
-            <a:ext cx="2468880" cy="685800"/>
-          </a:xfrm>
-          <a:prstGeom prst="rect">
-            <a:avLst/>
-          </a:prstGeom>
-          <a:noFill/>
-        </p:spPr>
-        <p:txBody>
-          <a:bodyPr wrap="square">
-            <a:spAutoFit/>
-          </a:bodyPr>
-          <a:lstStyle/>
-          <a:p>
-            <a:pPr algn="ctr"/>
-            <a:r>
-              <a:rPr sz="1400" b="1" i="0">
-                <a:solidFill>
-                  <a:srgbClr val="FFFFFF"/>
-                </a:solidFill>
-                <a:latin typeface="Calibri"/>
-              </a:rPr>
-              <a:t>Outdoor
-Robotics</a:t>
-            </a:r>
-          </a:p>
-        </p:txBody>
-      </p:sp>
-      <p:sp>
-        <p:nvSpPr>
-          <p:cNvPr id="17" name="TextBox 16"/>
-          <p:cNvSpPr txBox="1"/>
-          <p:nvPr/>
-        </p:nvSpPr>
-        <p:spPr>
-          <a:xfrm>
-            <a:off x="8778240" y="2423160"/>
-            <a:ext cx="2286000" cy="1737360"/>
-          </a:xfrm>
-          <a:prstGeom prst="rect">
-            <a:avLst/>
-          </a:prstGeom>
-          <a:noFill/>
-        </p:spPr>
-        <p:txBody>
-          <a:bodyPr wrap="square">
-            <a:spAutoFit/>
-          </a:bodyPr>
-          <a:lstStyle/>
-          <a:p>
-            <a:pPr algn="ctr"/>
-            <a:r>
-              <a:rPr sz="1200" b="0" i="0">
-                <a:solidFill>
-                  <a:srgbClr val="4C9BE8"/>
-                </a:solidFill>
-                <a:latin typeface="Calibri"/>
-              </a:rPr>
-              <a:t>Simulation
-→ Controlled env
-→ Unstructured env</a:t>
-            </a:r>
-          </a:p>
-        </p:txBody>
-      </p:sp>
-      <p:sp>
-        <p:nvSpPr>
-          <p:cNvPr id="18" name="Rectangle 17"/>
-          <p:cNvSpPr/>
-          <p:nvPr/>
-        </p:nvSpPr>
-        <p:spPr>
-          <a:xfrm>
-            <a:off x="365760" y="4434840"/>
-            <a:ext cx="11430000" cy="1371600"/>
-          </a:xfrm>
-          <a:prstGeom prst="rect">
-            <a:avLst/>
-          </a:prstGeom>
-          <a:solidFill>
-            <a:srgbClr val="EEF4FB"/>
-          </a:solidFill>
-          <a:ln w="12700">
-            <a:solidFill>
-              <a:srgbClr val="4C9BE8"/>
-            </a:solidFill>
-          </a:ln>
-        </p:spPr>
-        <p:style>
-          <a:lnRef idx="1">
-            <a:schemeClr val="accent1"/>
-          </a:lnRef>
-          <a:fillRef idx="3">
-            <a:schemeClr val="accent1"/>
-          </a:fillRef>
-          <a:effectRef idx="2">
-            <a:schemeClr val="accent1"/>
-          </a:effectRef>
-          <a:fontRef idx="minor">
-            <a:schemeClr val="lt1"/>
-          </a:fontRef>
-        </p:style>
-        <p:txBody>
-          <a:bodyPr rtlCol="0" anchor="ctr"/>
-          <a:lstStyle/>
-          <a:p>
-            <a:pPr algn="ctr"/>
-          </a:p>
-        </p:txBody>
-      </p:sp>
-      <p:sp>
-        <p:nvSpPr>
-          <p:cNvPr id="19" name="TextBox 18"/>
-          <p:cNvSpPr txBox="1"/>
-          <p:nvPr/>
-        </p:nvSpPr>
-        <p:spPr>
-          <a:xfrm>
-            <a:off x="548640" y="4526280"/>
-            <a:ext cx="11064240" cy="320040"/>
-          </a:xfrm>
-          <a:prstGeom prst="rect">
-            <a:avLst/>
-          </a:prstGeom>
-          <a:noFill/>
-        </p:spPr>
-        <p:txBody>
-          <a:bodyPr wrap="square">
-            <a:spAutoFit/>
-          </a:bodyPr>
-          <a:lstStyle/>
-          <a:p>
-            <a:pPr algn="l"/>
-            <a:r>
-              <a:rPr sz="1400" b="1" i="0">
-                <a:solidFill>
-                  <a:srgbClr val="1A4F8A"/>
-                </a:solidFill>
-                <a:latin typeface="Calibri"/>
-              </a:rPr>
-              <a:t>Structural requirement for two-step UDA:</a:t>
-            </a:r>
-          </a:p>
-        </p:txBody>
-      </p:sp>
-      <p:sp>
-        <p:nvSpPr>
-          <p:cNvPr id="20" name="TextBox 19"/>
-          <p:cNvSpPr txBox="1"/>
-          <p:nvPr/>
-        </p:nvSpPr>
-        <p:spPr>
-          <a:xfrm>
-            <a:off x="548640" y="4892040"/>
-            <a:ext cx="11064240" cy="822960"/>
-          </a:xfrm>
-          <a:prstGeom prst="rect">
-            <a:avLst/>
-          </a:prstGeom>
-          <a:noFill/>
-        </p:spPr>
-        <p:txBody>
-          <a:bodyPr wrap="square">
-            <a:spAutoFit/>
-          </a:bodyPr>
-          <a:lstStyle/>
-          <a:p>
-            <a:pPr algn="l"/>
-            <a:r>
-              <a:rPr sz="1300" b="0" i="0">
-                <a:solidFill>
-                  <a:srgbClr val="1A1A1A"/>
-                </a:solidFill>
-                <a:latin typeface="Calibri"/>
-              </a:rPr>
-              <a:t>Labeled synthetic source  ·  Accessible labeled intermediate domain  ·  Hard unlabeled final target
-Where the direct source→target gap is too large to bridge in one step.</a:t>
-            </a:r>
-          </a:p>
-        </p:txBody>
-      </p:sp>
+              <a:t>All four conditions improve, including night — best checkpoint at iter 5,000</a:t>
+            </a:r>
+          </a:p>
+        </p:txBody>
+      </p:sp>
+      <p:pic>
+        <p:nvPicPr>
+          <p:cNvPr id="5" name="Picture 4" descr="fig_step2_adaptation_curve_full.png"/>
+          <p:cNvPicPr>
+            <a:picLocks noChangeAspect="1"/>
+          </p:cNvPicPr>
+          <p:nvPr/>
+        </p:nvPicPr>
+        <p:blipFill>
+          <a:blip r:embed="rId2"/>
+          <a:stretch>
+            <a:fillRect/>
+          </a:stretch>
+        </p:blipFill>
+        <p:spPr>
+          <a:xfrm>
+            <a:off x="914400" y="1005840"/>
+            <a:ext cx="10332720" cy="9184640"/>
+          </a:xfrm>
+          <a:prstGeom prst="rect">
+            <a:avLst/>
+          </a:prstGeom>
+        </p:spPr>
+      </p:pic>
     </p:spTree>
   </p:cSld>
   <p:clrMapOvr>

</xml_diff>